<commit_message>
AGRI CLUSTER v2 - Phase 6: deck, release build and judge notes
Deck: farmer-journey slide with Spandana's season, seven roles with privacy and notifications, corrected 1-acre water figure (15,000 L), fresh screenshots. Rebuilt single-file release and zip; HOW-TO-OPEN describes the 21-step tour.
</commit_message>
<xml_diff>
--- a/deck/AgriCluster-pitch.pptx
+++ b/deck/AgriCluster-pitch.pptx
@@ -513,7 +513,7 @@
           <a:p>
             <a:r>
               <a:rPr lang="en-US" dirty="0"/>
-              <a:t>AgriCluster is a smart-farming platform for small farms. Instead of trying to make every small farm a fully equipped smart farm on its own, we connect nearby farms into one intelligent cluster. The cluster shares data, machinery, labour, expertise and market access. What you see on the phone is a working prototype: a farmer's dashboard in our demonstration cluster in Mysuru district.</a:t>
+              <a:t>AgriCluster helps a small farmer make the season's big decisions: which crop, which method, how much to invest, and who to sell to. It connects nearby farms into one cluster that shares machinery, labour, expertise and market access. Right crop, right technology, right resource, right investment, right support. On the phone is the working prototype: Spandana's dashboard, a farmer with 1 acre near Chamarajanagara.</a:t>
             </a:r>
             <a:endParaRPr lang="en-US" dirty="0"/>
           </a:p>
@@ -1041,7 +1041,7 @@
           <a:p>
             <a:r>
               <a:rPr lang="en-US" dirty="0"/>
-              <a:t>Our answer is to make the cluster smart rather than every individual farm. AgriCluster is a shared layer around a group of neighbouring farms. It connects the people and resources, turns farm, weather, sensor and market data into suggestions that explain themselves, and coordinates what is shared: machinery, labour, expertise and harvests. The map shows our demonstration cluster: 128 farms in six villages around shared infrastructure. One principle runs through everything: the platform recommends, the farmer decides.</a:t>
+              <a:t>Our answer has three parts. First, guide the farmer through the decisions that shape a season: crop, method, investment and plan, with every suggestion explained. Second, connect the farmer to the people and resources around them: machinery and technology providers, labour, experts, community groups and buyers. Third, coordinate what is shared, so small lots and scarce tractors are planned across the cluster. The map shows our demonstration cluster: 128 farms in six villages. One principle runs through everything: the platform recommends, the farmer decides.</a:t>
             </a:r>
             <a:endParaRPr lang="en-US" dirty="0"/>
           </a:p>
@@ -1129,7 +1129,7 @@
           <a:p>
             <a:r>
               <a:rPr lang="en-US" dirty="0"/>
-              <a:t>The platform works in seven steps: connect, collect, analyze, recommend, coordinate, act and measure. Here is one real example from the prototype. Rain is 82 percent likely this evening, and Field 1's soil moisture is already above what the tomato crop needs. So AgriCluster suggests delaying irrigation by a day, and shows exactly which data led to that. The farmer accepts with one tap, and the schedule moves. That single decision avoids roughly 36,000 litres of water and 11 kilowatt-hours of pumping, an indicative estimate.</a:t>
+              <a:t>At the heart of AgriCluster is the farmer's journey, from farm information to a buyer. Here is Spandana, from our demo. She has 1 acre near Chamarajanagara, red soil, drip irrigation and 1.5 lakh rupees to invest. After a few questions, AgriCluster ranks crops for her land and budget; tomato is the best match, and the card explains why. It then shows only the methods that suit tomato on her farm; precision farming fits her drip and solar. It splits her budget across the season and suggests renting the tractor and sprayer rather than buying them. It builds a calendar to her first harvest around 4 October, and matches the labour, experts and support she will need. At harvest, she lists 2,000 kilograms of Grade A tomato, choosing what buyers can see. A buyer requests, and she decides. Every figure is an indicative range, never a guarantee.</a:t>
             </a:r>
             <a:endParaRPr lang="en-US" dirty="0"/>
           </a:p>
@@ -1217,7 +1217,7 @@
           <a:p>
             <a:r>
               <a:rPr lang="en-US" dirty="0"/>
-              <a:t>This is what we call cluster intelligence. AgriCluster combines farm and crop data, soil moisture, weather, water and energy, machinery, labour, experts and market demand. For one farmer, it produces a suggestion that explains itself, as on the right. Across the cluster the same signals become patterns a coordinator can act on: 24 farms about to irrigate before rain, 6 tomato farms under stress, 14 tractor requests for 9 tractors, and 42 tonnes of tomato coming against 35 tonnes of buyer demand.</a:t>
+              <a:t>Once the season is running, the same approach continues day to day. AgriCluster combines farm and crop data, soil moisture, weather, water and energy, machinery, labour, experts and market demand. For one farmer, it produces a suggestion that explains itself, as on the right: rain is 82 percent likely tonight and Field 1 already has enough moisture, so delaying irrigation by a day could save about 15,000 litres of water. Across the cluster the same signals become patterns a coordinator can act on: 24 farms about to irrigate before rain, 6 tomato farms under stress, 14 tractor requests for 9 tractors, and 42 tonnes of tomato coming against 35 tonnes of buyer demand.</a:t>
             </a:r>
             <a:endParaRPr lang="en-US" dirty="0"/>
           </a:p>
@@ -1305,7 +1305,7 @@
           <a:p>
             <a:r>
               <a:rPr lang="en-US" dirty="0"/>
-              <a:t>The product has six connected roles: farmer, cluster manager, buyer, machinery owner, labour and expert. They all work on the same shared records. When the farmer requests a tractor, the owner accepts it. When the farmer lists a harvest, the buyer sees it. When the farmer delays irrigation, the cluster dashboard updates. [If showing the live demo, switch now: open the prototype and use the Guided demo button.]</a:t>
+              <a:t>The product has seven connected roles: farmer, buyer, machinery and technology owner, labour, expert, community organiser and cluster manager. They all work on the same shared records, and every request and reply sends a notification to the other side. Privacy is built in: a buyer sees only what the farmer chose to share on a listing, as on this screen, never her phone number or finances. [If showing the live demo, switch now: open the prototype and use the Guided demo button. It walks through all 21 steps.]</a:t>
             </a:r>
             <a:endParaRPr lang="en-US" dirty="0"/>
           </a:p>
@@ -1393,7 +1393,7 @@
           <a:p>
             <a:r>
               <a:rPr lang="en-US" dirty="0"/>
-              <a:t>We will measure impact against a baseline, not promise it. The pilot targets are 15 to 20 percent less avoidable water use, 10 to 15 percent better input efficiency, 10 percent less crop loss, and 5 to 10 percent better market realisation. These are illustrative goals, not guaranteed outcomes. The prototype already shows the mechanism: one accepted suggestion avoids about 36,000 litres of water; the cluster sees 42 tonnes of tomato against 35 tonnes of demand a week ahead; and a tractor shortage is visible a day before it happens.</a:t>
+              <a:t>We will measure impact against a baseline, not promise it. The pilot targets are 15 to 20 percent less avoidable water use, 10 to 15 percent better input efficiency, 10 percent less crop loss, and 5 to 10 percent better market realisation. These are illustrative goals, not guaranteed outcomes. The prototype already shows the mechanism: on a single acre, one accepted suggestion avoids about 15,000 litres of water; the cluster sees 42 tonnes of tomato against 35 tonnes of demand a week ahead; and a tractor shortage is visible a day before it happens.</a:t>
             </a:r>
             <a:endParaRPr lang="en-US" dirty="0"/>
           </a:p>
@@ -2006,23 +2006,23 @@
         <p:spPr>
           <a:xfrm>
             <a:off x="731520" y="2926080"/>
-            <a:ext cx="7132320" cy="548640"/>
-          </a:xfrm>
-          <a:prstGeom prst="rect">
-            <a:avLst/>
-          </a:prstGeom>
-          <a:noFill/>
-          <a:ln/>
-        </p:spPr>
-        <p:txBody>
-          <a:bodyPr wrap="square" lIns="0" tIns="0" rIns="0" bIns="0" rtlCol="0" anchor="ctr"/>
-          <a:lstStyle/>
-          <a:p>
-            <a:pPr indent="0" marL="0">
-              <a:buNone/>
-            </a:pPr>
-            <a:r>
-              <a:rPr lang="en-US" sz="2400" dirty="0">
+            <a:ext cx="7498080" cy="822960"/>
+          </a:xfrm>
+          <a:prstGeom prst="rect">
+            <a:avLst/>
+          </a:prstGeom>
+          <a:noFill/>
+          <a:ln/>
+        </p:spPr>
+        <p:txBody>
+          <a:bodyPr wrap="square" lIns="0" tIns="0" rIns="0" bIns="0" rtlCol="0" anchor="t"/>
+          <a:lstStyle/>
+          <a:p>
+            <a:pPr indent="0" marL="0">
+              <a:buNone/>
+            </a:pPr>
+            <a:r>
+              <a:rPr lang="en-US" sz="2200" dirty="0">
                 <a:solidFill>
                   <a:srgbClr val="D6E8DC"/>
                 </a:solidFill>
@@ -2030,9 +2030,9 @@
                 <a:ea typeface="Segoe UI Semibold" pitchFamily="34" charset="-122"/>
                 <a:cs typeface="Segoe UI Semibold" pitchFamily="34" charset="-120"/>
               </a:rPr>
-              <a:t>Small Farms. Shared Resources. Smarter Decisions.</a:t>
-            </a:r>
-            <a:endParaRPr lang="en-US" sz="2400" dirty="0"/>
+              <a:t>Right Crop. Right Technology. Right Resource. Right Investment. Right Support.</a:t>
+            </a:r>
+            <a:endParaRPr lang="en-US" sz="2200" dirty="0"/>
           </a:p>
         </p:txBody>
       </p:sp>
@@ -2045,7 +2045,7 @@
         <p:spPr>
           <a:xfrm>
             <a:off x="731520" y="3703320"/>
-            <a:ext cx="6583680" cy="1097280"/>
+            <a:ext cx="6583680" cy="1280160"/>
           </a:xfrm>
           <a:prstGeom prst="rect">
             <a:avLst/>
@@ -2072,7 +2072,7 @@
                 <a:ea typeface="Segoe UI" pitchFamily="34" charset="-122"/>
                 <a:cs typeface="Segoe UI" pitchFamily="34" charset="-120"/>
               </a:rPr>
-              <a:t>Cluster intelligence that connects neighbouring small farms, shares their machinery, labour and expertise, and coordinates their harvests with buyers.</a:t>
+              <a:t>Guides a small farmer from farm information to a buyer: the right crop, method, investment and support, with machinery, labour, experts and buyers shared across a cluster of nearby farms.</a:t>
             </a:r>
             <a:endParaRPr lang="en-US" sz="1700" dirty="0"/>
           </a:p>
@@ -4837,7 +4837,7 @@
                 <a:ea typeface="Segoe UI Semibold" pitchFamily="34" charset="-122"/>
                 <a:cs typeface="Segoe UI Semibold" pitchFamily="34" charset="-120"/>
               </a:rPr>
-              <a:t>Small Farms. Shared Resources. Smarter Decisions.</a:t>
+              <a:t>Right Crop. Right Technology. Right Resource. Right Investment. Right Support.</a:t>
             </a:r>
             <a:endParaRPr lang="en-US" sz="1400" dirty="0"/>
           </a:p>
@@ -7197,7 +7197,7 @@
                 <a:ea typeface="Segoe UI Semibold" pitchFamily="34" charset="-122"/>
                 <a:cs typeface="Segoe UI Semibold" pitchFamily="34" charset="-120"/>
               </a:rPr>
-              <a:t>Connect</a:t>
+              <a:t>Guide</a:t>
             </a:r>
             <a:endParaRPr lang="en-US" sz="1700" dirty="0"/>
           </a:p>
@@ -7236,7 +7236,7 @@
                 <a:ea typeface="Segoe UI" pitchFamily="34" charset="-122"/>
                 <a:cs typeface="Segoe UI" pitchFamily="34" charset="-120"/>
               </a:rPr>
-              <a:t>Farmers, farms, machinery, labour, experts and buyers in one cluster.</a:t>
+              <a:t>From farm details to the right crop, method, investment and cropping plan, with every suggestion explained.</a:t>
             </a:r>
             <a:endParaRPr lang="en-US" sz="1400" dirty="0"/>
           </a:p>
@@ -7275,7 +7275,7 @@
                 <a:ea typeface="Segoe UI Semibold" pitchFamily="34" charset="-122"/>
                 <a:cs typeface="Segoe UI Semibold" pitchFamily="34" charset="-120"/>
               </a:rPr>
-              <a:t>Understand</a:t>
+              <a:t>Connect</a:t>
             </a:r>
             <a:endParaRPr lang="en-US" sz="1700" dirty="0"/>
           </a:p>
@@ -7314,7 +7314,7 @@
                 <a:ea typeface="Segoe UI" pitchFamily="34" charset="-122"/>
                 <a:cs typeface="Segoe UI" pitchFamily="34" charset="-120"/>
               </a:rPr>
-              <a:t>Farm, weather, sensor, resource and market data turned into suggestions that explain themselves.</a:t>
+              <a:t>Farmers, machinery and technology providers, labour, experts, community groups and buyers in one cluster.</a:t>
             </a:r>
             <a:endParaRPr lang="en-US" sz="1400" dirty="0"/>
           </a:p>
@@ -7392,7 +7392,7 @@
                 <a:ea typeface="Segoe UI" pitchFamily="34" charset="-122"/>
                 <a:cs typeface="Segoe UI" pitchFamily="34" charset="-120"/>
               </a:rPr>
-              <a:t>Shared machinery, labour and expertise, and pooled harvests matched to buyer demand.</a:t>
+              <a:t>Shared resources, pooled harvests matched to buyer demand, and a notification for every request and reply.</a:t>
             </a:r>
             <a:endParaRPr lang="en-US" sz="1400" dirty="0"/>
           </a:p>
@@ -7467,12 +7467,12 @@
         </p:nvSpPr>
         <p:spPr>
           <a:xfrm>
-            <a:off x="6446520" y="1737360"/>
-            <a:ext cx="5212080" cy="3945255"/>
+            <a:off x="6508678" y="1737360"/>
+            <a:ext cx="5087764" cy="3886200"/>
           </a:xfrm>
           <a:prstGeom prst="roundRect">
             <a:avLst>
-              <a:gd name="adj" fmla="val 1854"/>
+              <a:gd name="adj" fmla="val 1882"/>
             </a:avLst>
           </a:prstGeom>
           <a:solidFill>
@@ -7509,8 +7509,8 @@
         </p:blipFill>
         <p:spPr>
           <a:xfrm>
-            <a:off x="6501384" y="1792224"/>
-            <a:ext cx="5102352" cy="3835527"/>
+            <a:off x="6563542" y="1792224"/>
+            <a:ext cx="4978036" cy="3776472"/>
           </a:xfrm>
           <a:prstGeom prst="rect">
             <a:avLst/>
@@ -7621,7 +7621,7 @@
                 <a:ea typeface="Segoe UI Semibold" pitchFamily="34" charset="-122"/>
                 <a:cs typeface="Segoe UI Semibold" pitchFamily="34" charset="-120"/>
               </a:rPr>
-              <a:t>05   HOW IT WORKS</a:t>
+              <a:t>05   THE FARMER'S JOURNEY</a:t>
             </a:r>
             <a:endParaRPr lang="en-US" sz="1100" dirty="0"/>
           </a:p>
@@ -7660,7 +7660,7 @@
                 <a:ea typeface="Segoe UI Semibold" pitchFamily="34" charset="-122"/>
                 <a:cs typeface="Segoe UI Semibold" pitchFamily="34" charset="-120"/>
               </a:rPr>
-              <a:t>From data to coordinated action</a:t>
+              <a:t>From farm information to a buyer, one decision at a time</a:t>
             </a:r>
             <a:endParaRPr lang="en-US" sz="3000" dirty="0"/>
           </a:p>
@@ -7752,8 +7752,8 @@
         </p:nvSpPr>
         <p:spPr>
           <a:xfrm>
-            <a:off x="548640" y="1828800"/>
-            <a:ext cx="1678577" cy="685800"/>
+            <a:off x="548640" y="1737360"/>
+            <a:ext cx="1191463" cy="566928"/>
           </a:xfrm>
           <a:prstGeom prst="homePlate">
             <a:avLst/>
@@ -7777,24 +7777,24 @@
         </p:nvSpPr>
         <p:spPr>
           <a:xfrm>
-            <a:off x="640080" y="1828800"/>
-            <a:ext cx="1267097" cy="685800"/>
-          </a:xfrm>
-          <a:prstGeom prst="rect">
-            <a:avLst/>
-          </a:prstGeom>
-          <a:noFill/>
-          <a:ln/>
-        </p:spPr>
-        <p:txBody>
-          <a:bodyPr wrap="square" lIns="0" tIns="0" rIns="0" bIns="0" rtlCol="0" anchor="ctr"/>
-          <a:lstStyle/>
-          <a:p>
-            <a:pPr algn="l" indent="0" marL="0">
-              <a:buNone/>
-            </a:pPr>
-            <a:r>
-              <a:rPr lang="en-US" sz="1250" dirty="0">
+            <a:off x="621792" y="1737360"/>
+            <a:ext cx="917143" cy="566928"/>
+          </a:xfrm>
+          <a:prstGeom prst="rect">
+            <a:avLst/>
+          </a:prstGeom>
+          <a:noFill/>
+          <a:ln/>
+        </p:spPr>
+        <p:txBody>
+          <a:bodyPr wrap="square" lIns="0" tIns="0" rIns="0" bIns="0" rtlCol="0" anchor="ctr"/>
+          <a:lstStyle/>
+          <a:p>
+            <a:pPr algn="ctr" indent="0" marL="0">
+              <a:buNone/>
+            </a:pPr>
+            <a:r>
+              <a:rPr lang="en-US" sz="1050" dirty="0">
                 <a:solidFill>
                   <a:srgbClr val="FFFFFF"/>
                 </a:solidFill>
@@ -7802,61 +7802,22 @@
                 <a:ea typeface="Segoe UI Semibold" pitchFamily="34" charset="-122"/>
                 <a:cs typeface="Segoe UI Semibold" pitchFamily="34" charset="-120"/>
               </a:rPr>
-              <a:t>Connect</a:t>
-            </a:r>
-            <a:endParaRPr lang="en-US" sz="1250" dirty="0"/>
-          </a:p>
-        </p:txBody>
-      </p:sp>
-      <p:sp>
-        <p:nvSpPr>
-          <p:cNvPr id="8" name="Text 6"/>
-          <p:cNvSpPr/>
-          <p:nvPr/>
-        </p:nvSpPr>
-        <p:spPr>
-          <a:xfrm>
-            <a:off x="640080" y="2651760"/>
-            <a:ext cx="1449977" cy="914400"/>
-          </a:xfrm>
-          <a:prstGeom prst="rect">
-            <a:avLst/>
-          </a:prstGeom>
-          <a:noFill/>
-          <a:ln/>
-        </p:spPr>
-        <p:txBody>
-          <a:bodyPr wrap="square" lIns="0" tIns="0" rIns="0" bIns="0" rtlCol="0" anchor="t"/>
-          <a:lstStyle/>
-          <a:p>
-            <a:pPr indent="0" marL="0">
-              <a:buNone/>
-            </a:pPr>
-            <a:r>
-              <a:rPr lang="en-US" sz="1200" dirty="0">
-                <a:solidFill>
-                  <a:srgbClr val="56615A"/>
-                </a:solidFill>
-                <a:latin typeface="Segoe UI" pitchFamily="34" charset="0"/>
-                <a:ea typeface="Segoe UI" pitchFamily="34" charset="-122"/>
-                <a:cs typeface="Segoe UI" pitchFamily="34" charset="-120"/>
-              </a:rPr>
-              <a:t>Farms, resources, experts and buyers join the cluster</a:t>
-            </a:r>
-            <a:endParaRPr lang="en-US" sz="1200" dirty="0"/>
-          </a:p>
-        </p:txBody>
-      </p:sp>
-      <p:sp>
-        <p:nvSpPr>
-          <p:cNvPr id="9" name="Shape 7"/>
-          <p:cNvSpPr/>
-          <p:nvPr/>
-        </p:nvSpPr>
-        <p:spPr>
-          <a:xfrm>
-            <a:off x="2117489" y="1828800"/>
-            <a:ext cx="1678577" cy="685800"/>
+              <a:t>Farm</a:t>
+            </a:r>
+            <a:endParaRPr lang="en-US" sz="1050" dirty="0"/>
+          </a:p>
+        </p:txBody>
+      </p:sp>
+      <p:sp>
+        <p:nvSpPr>
+          <p:cNvPr id="8" name="Shape 6"/>
+          <p:cNvSpPr/>
+          <p:nvPr/>
+        </p:nvSpPr>
+        <p:spPr>
+          <a:xfrm>
+            <a:off x="1648663" y="1737360"/>
+            <a:ext cx="1191463" cy="566928"/>
           </a:xfrm>
           <a:prstGeom prst="chevron">
             <a:avLst/>
@@ -7874,14 +7835,14 @@
       </p:sp>
       <p:sp>
         <p:nvSpPr>
-          <p:cNvPr id="10" name="Text 8"/>
-          <p:cNvSpPr/>
-          <p:nvPr/>
-        </p:nvSpPr>
-        <p:spPr>
-          <a:xfrm>
-            <a:off x="2428385" y="1828800"/>
-            <a:ext cx="1111649" cy="685800"/>
+          <p:cNvPr id="9" name="Text 7"/>
+          <p:cNvSpPr/>
+          <p:nvPr/>
+        </p:nvSpPr>
+        <p:spPr>
+          <a:xfrm>
+            <a:off x="1922983" y="1737360"/>
+            <a:ext cx="880567" cy="566928"/>
           </a:xfrm>
           <a:prstGeom prst="rect">
             <a:avLst/>
@@ -7897,7 +7858,7 @@
               <a:buNone/>
             </a:pPr>
             <a:r>
-              <a:rPr lang="en-US" sz="1250" dirty="0">
+              <a:rPr lang="en-US" sz="1050" dirty="0">
                 <a:solidFill>
                   <a:srgbClr val="FFFFFF"/>
                 </a:solidFill>
@@ -7905,61 +7866,22 @@
                 <a:ea typeface="Segoe UI Semibold" pitchFamily="34" charset="-122"/>
                 <a:cs typeface="Segoe UI Semibold" pitchFamily="34" charset="-120"/>
               </a:rPr>
-              <a:t>Collect</a:t>
-            </a:r>
-            <a:endParaRPr lang="en-US" sz="1250" dirty="0"/>
-          </a:p>
-        </p:txBody>
-      </p:sp>
-      <p:sp>
-        <p:nvSpPr>
-          <p:cNvPr id="11" name="Text 9"/>
-          <p:cNvSpPr/>
-          <p:nvPr/>
-        </p:nvSpPr>
-        <p:spPr>
-          <a:xfrm>
-            <a:off x="2208929" y="2651760"/>
-            <a:ext cx="1449977" cy="914400"/>
-          </a:xfrm>
-          <a:prstGeom prst="rect">
-            <a:avLst/>
-          </a:prstGeom>
-          <a:noFill/>
-          <a:ln/>
-        </p:spPr>
-        <p:txBody>
-          <a:bodyPr wrap="square" lIns="0" tIns="0" rIns="0" bIns="0" rtlCol="0" anchor="t"/>
-          <a:lstStyle/>
-          <a:p>
-            <a:pPr indent="0" marL="0">
-              <a:buNone/>
-            </a:pPr>
-            <a:r>
-              <a:rPr lang="en-US" sz="1200" dirty="0">
-                <a:solidFill>
-                  <a:srgbClr val="56615A"/>
-                </a:solidFill>
-                <a:latin typeface="Segoe UI" pitchFamily="34" charset="0"/>
-                <a:ea typeface="Segoe UI" pitchFamily="34" charset="-122"/>
-                <a:cs typeface="Segoe UI" pitchFamily="34" charset="-120"/>
-              </a:rPr>
-              <a:t>Farmer input, weather, sensors, energy and market data</a:t>
-            </a:r>
-            <a:endParaRPr lang="en-US" sz="1200" dirty="0"/>
-          </a:p>
-        </p:txBody>
-      </p:sp>
-      <p:sp>
-        <p:nvSpPr>
-          <p:cNvPr id="12" name="Shape 10"/>
-          <p:cNvSpPr/>
-          <p:nvPr/>
-        </p:nvSpPr>
-        <p:spPr>
-          <a:xfrm>
-            <a:off x="3686338" y="1828800"/>
-            <a:ext cx="1678577" cy="685800"/>
+              <a:t>Goal</a:t>
+            </a:r>
+            <a:endParaRPr lang="en-US" sz="1050" dirty="0"/>
+          </a:p>
+        </p:txBody>
+      </p:sp>
+      <p:sp>
+        <p:nvSpPr>
+          <p:cNvPr id="10" name="Shape 8"/>
+          <p:cNvSpPr/>
+          <p:nvPr/>
+        </p:nvSpPr>
+        <p:spPr>
+          <a:xfrm>
+            <a:off x="2748686" y="1737360"/>
+            <a:ext cx="1191463" cy="566928"/>
           </a:xfrm>
           <a:prstGeom prst="chevron">
             <a:avLst/>
@@ -7977,14 +7899,14 @@
       </p:sp>
       <p:sp>
         <p:nvSpPr>
-          <p:cNvPr id="13" name="Text 11"/>
-          <p:cNvSpPr/>
-          <p:nvPr/>
-        </p:nvSpPr>
-        <p:spPr>
-          <a:xfrm>
-            <a:off x="3997234" y="1828800"/>
-            <a:ext cx="1111649" cy="685800"/>
+          <p:cNvPr id="11" name="Text 9"/>
+          <p:cNvSpPr/>
+          <p:nvPr/>
+        </p:nvSpPr>
+        <p:spPr>
+          <a:xfrm>
+            <a:off x="3023006" y="1737360"/>
+            <a:ext cx="880567" cy="566928"/>
           </a:xfrm>
           <a:prstGeom prst="rect">
             <a:avLst/>
@@ -8000,7 +7922,7 @@
               <a:buNone/>
             </a:pPr>
             <a:r>
-              <a:rPr lang="en-US" sz="1250" dirty="0">
+              <a:rPr lang="en-US" sz="1050" dirty="0">
                 <a:solidFill>
                   <a:srgbClr val="FFFFFF"/>
                 </a:solidFill>
@@ -8008,61 +7930,22 @@
                 <a:ea typeface="Segoe UI Semibold" pitchFamily="34" charset="-122"/>
                 <a:cs typeface="Segoe UI Semibold" pitchFamily="34" charset="-120"/>
               </a:rPr>
-              <a:t>Analyze</a:t>
-            </a:r>
-            <a:endParaRPr lang="en-US" sz="1250" dirty="0"/>
-          </a:p>
-        </p:txBody>
-      </p:sp>
-      <p:sp>
-        <p:nvSpPr>
-          <p:cNvPr id="14" name="Text 12"/>
-          <p:cNvSpPr/>
-          <p:nvPr/>
-        </p:nvSpPr>
-        <p:spPr>
-          <a:xfrm>
-            <a:off x="3777778" y="2651760"/>
-            <a:ext cx="1449977" cy="914400"/>
-          </a:xfrm>
-          <a:prstGeom prst="rect">
-            <a:avLst/>
-          </a:prstGeom>
-          <a:noFill/>
-          <a:ln/>
-        </p:spPr>
-        <p:txBody>
-          <a:bodyPr wrap="square" lIns="0" tIns="0" rIns="0" bIns="0" rtlCol="0" anchor="t"/>
-          <a:lstStyle/>
-          <a:p>
-            <a:pPr indent="0" marL="0">
-              <a:buNone/>
-            </a:pPr>
-            <a:r>
-              <a:rPr lang="en-US" sz="1200" dirty="0">
-                <a:solidFill>
-                  <a:srgbClr val="56615A"/>
-                </a:solidFill>
-                <a:latin typeface="Segoe UI" pitchFamily="34" charset="0"/>
-                <a:ea typeface="Segoe UI" pitchFamily="34" charset="-122"/>
-                <a:cs typeface="Segoe UI" pitchFamily="34" charset="-120"/>
-              </a:rPr>
-              <a:t>Rules check the data against each crop and plan</a:t>
-            </a:r>
-            <a:endParaRPr lang="en-US" sz="1200" dirty="0"/>
-          </a:p>
-        </p:txBody>
-      </p:sp>
-      <p:sp>
-        <p:nvSpPr>
-          <p:cNvPr id="15" name="Shape 13"/>
-          <p:cNvSpPr/>
-          <p:nvPr/>
-        </p:nvSpPr>
-        <p:spPr>
-          <a:xfrm>
-            <a:off x="5255187" y="1828800"/>
-            <a:ext cx="1678577" cy="685800"/>
+              <a:t>Crop</a:t>
+            </a:r>
+            <a:endParaRPr lang="en-US" sz="1050" dirty="0"/>
+          </a:p>
+        </p:txBody>
+      </p:sp>
+      <p:sp>
+        <p:nvSpPr>
+          <p:cNvPr id="12" name="Shape 10"/>
+          <p:cNvSpPr/>
+          <p:nvPr/>
+        </p:nvSpPr>
+        <p:spPr>
+          <a:xfrm>
+            <a:off x="3848710" y="1737360"/>
+            <a:ext cx="1191463" cy="566928"/>
           </a:xfrm>
           <a:prstGeom prst="chevron">
             <a:avLst/>
@@ -8080,14 +7963,14 @@
       </p:sp>
       <p:sp>
         <p:nvSpPr>
-          <p:cNvPr id="16" name="Text 14"/>
-          <p:cNvSpPr/>
-          <p:nvPr/>
-        </p:nvSpPr>
-        <p:spPr>
-          <a:xfrm>
-            <a:off x="5566083" y="1828800"/>
-            <a:ext cx="1111649" cy="685800"/>
+          <p:cNvPr id="13" name="Text 11"/>
+          <p:cNvSpPr/>
+          <p:nvPr/>
+        </p:nvSpPr>
+        <p:spPr>
+          <a:xfrm>
+            <a:off x="4123030" y="1737360"/>
+            <a:ext cx="880567" cy="566928"/>
           </a:xfrm>
           <a:prstGeom prst="rect">
             <a:avLst/>
@@ -8103,7 +7986,7 @@
               <a:buNone/>
             </a:pPr>
             <a:r>
-              <a:rPr lang="en-US" sz="1250" dirty="0">
+              <a:rPr lang="en-US" sz="1050" dirty="0">
                 <a:solidFill>
                   <a:srgbClr val="FFFFFF"/>
                 </a:solidFill>
@@ -8111,61 +7994,22 @@
                 <a:ea typeface="Segoe UI Semibold" pitchFamily="34" charset="-122"/>
                 <a:cs typeface="Segoe UI Semibold" pitchFamily="34" charset="-120"/>
               </a:rPr>
-              <a:t>Recommend</a:t>
-            </a:r>
-            <a:endParaRPr lang="en-US" sz="1250" dirty="0"/>
-          </a:p>
-        </p:txBody>
-      </p:sp>
-      <p:sp>
-        <p:nvSpPr>
-          <p:cNvPr id="17" name="Text 15"/>
-          <p:cNvSpPr/>
-          <p:nvPr/>
-        </p:nvSpPr>
-        <p:spPr>
-          <a:xfrm>
-            <a:off x="5346627" y="2651760"/>
-            <a:ext cx="1449977" cy="914400"/>
-          </a:xfrm>
-          <a:prstGeom prst="rect">
-            <a:avLst/>
-          </a:prstGeom>
-          <a:noFill/>
-          <a:ln/>
-        </p:spPr>
-        <p:txBody>
-          <a:bodyPr wrap="square" lIns="0" tIns="0" rIns="0" bIns="0" rtlCol="0" anchor="t"/>
-          <a:lstStyle/>
-          <a:p>
-            <a:pPr indent="0" marL="0">
-              <a:buNone/>
-            </a:pPr>
-            <a:r>
-              <a:rPr lang="en-US" sz="1200" dirty="0">
-                <a:solidFill>
-                  <a:srgbClr val="56615A"/>
-                </a:solidFill>
-                <a:latin typeface="Segoe UI" pitchFamily="34" charset="0"/>
-                <a:ea typeface="Segoe UI" pitchFamily="34" charset="-122"/>
-                <a:cs typeface="Segoe UI" pitchFamily="34" charset="-120"/>
-              </a:rPr>
-              <a:t>A suggestion with its reasons and data</a:t>
-            </a:r>
-            <a:endParaRPr lang="en-US" sz="1200" dirty="0"/>
-          </a:p>
-        </p:txBody>
-      </p:sp>
-      <p:sp>
-        <p:nvSpPr>
-          <p:cNvPr id="18" name="Shape 16"/>
-          <p:cNvSpPr/>
-          <p:nvPr/>
-        </p:nvSpPr>
-        <p:spPr>
-          <a:xfrm>
-            <a:off x="6824037" y="1828800"/>
-            <a:ext cx="1678577" cy="685800"/>
+              <a:t>Method</a:t>
+            </a:r>
+            <a:endParaRPr lang="en-US" sz="1050" dirty="0"/>
+          </a:p>
+        </p:txBody>
+      </p:sp>
+      <p:sp>
+        <p:nvSpPr>
+          <p:cNvPr id="14" name="Shape 12"/>
+          <p:cNvSpPr/>
+          <p:nvPr/>
+        </p:nvSpPr>
+        <p:spPr>
+          <a:xfrm>
+            <a:off x="4948733" y="1737360"/>
+            <a:ext cx="1191463" cy="566928"/>
           </a:xfrm>
           <a:prstGeom prst="chevron">
             <a:avLst/>
@@ -8183,14 +8027,14 @@
       </p:sp>
       <p:sp>
         <p:nvSpPr>
-          <p:cNvPr id="19" name="Text 17"/>
-          <p:cNvSpPr/>
-          <p:nvPr/>
-        </p:nvSpPr>
-        <p:spPr>
-          <a:xfrm>
-            <a:off x="7134933" y="1828800"/>
-            <a:ext cx="1111649" cy="685800"/>
+          <p:cNvPr id="15" name="Text 13"/>
+          <p:cNvSpPr/>
+          <p:nvPr/>
+        </p:nvSpPr>
+        <p:spPr>
+          <a:xfrm>
+            <a:off x="5223053" y="1737360"/>
+            <a:ext cx="880567" cy="566928"/>
           </a:xfrm>
           <a:prstGeom prst="rect">
             <a:avLst/>
@@ -8206,7 +8050,7 @@
               <a:buNone/>
             </a:pPr>
             <a:r>
-              <a:rPr lang="en-US" sz="1250" dirty="0">
+              <a:rPr lang="en-US" sz="1050" dirty="0">
                 <a:solidFill>
                   <a:srgbClr val="FFFFFF"/>
                 </a:solidFill>
@@ -8214,67 +8058,28 @@
                 <a:ea typeface="Segoe UI Semibold" pitchFamily="34" charset="-122"/>
                 <a:cs typeface="Segoe UI Semibold" pitchFamily="34" charset="-120"/>
               </a:rPr>
-              <a:t>Coordinate</a:t>
-            </a:r>
-            <a:endParaRPr lang="en-US" sz="1250" dirty="0"/>
-          </a:p>
-        </p:txBody>
-      </p:sp>
-      <p:sp>
-        <p:nvSpPr>
-          <p:cNvPr id="20" name="Text 18"/>
-          <p:cNvSpPr/>
-          <p:nvPr/>
-        </p:nvSpPr>
-        <p:spPr>
-          <a:xfrm>
-            <a:off x="6915477" y="2651760"/>
-            <a:ext cx="1449977" cy="914400"/>
-          </a:xfrm>
-          <a:prstGeom prst="rect">
-            <a:avLst/>
-          </a:prstGeom>
-          <a:noFill/>
-          <a:ln/>
-        </p:spPr>
-        <p:txBody>
-          <a:bodyPr wrap="square" lIns="0" tIns="0" rIns="0" bIns="0" rtlCol="0" anchor="t"/>
-          <a:lstStyle/>
-          <a:p>
-            <a:pPr indent="0" marL="0">
-              <a:buNone/>
-            </a:pPr>
-            <a:r>
-              <a:rPr lang="en-US" sz="1200" dirty="0">
-                <a:solidFill>
-                  <a:srgbClr val="56615A"/>
-                </a:solidFill>
-                <a:latin typeface="Segoe UI" pitchFamily="34" charset="0"/>
-                <a:ea typeface="Segoe UI" pitchFamily="34" charset="-122"/>
-                <a:cs typeface="Segoe UI" pitchFamily="34" charset="-120"/>
-              </a:rPr>
-              <a:t>Shared machinery, labour and buyers across farms</a:t>
-            </a:r>
-            <a:endParaRPr lang="en-US" sz="1200" dirty="0"/>
-          </a:p>
-        </p:txBody>
-      </p:sp>
-      <p:sp>
-        <p:nvSpPr>
-          <p:cNvPr id="21" name="Shape 19"/>
-          <p:cNvSpPr/>
-          <p:nvPr/>
-        </p:nvSpPr>
-        <p:spPr>
-          <a:xfrm>
-            <a:off x="8392886" y="1828800"/>
-            <a:ext cx="1678577" cy="685800"/>
+              <a:t>Investment</a:t>
+            </a:r>
+            <a:endParaRPr lang="en-US" sz="1050" dirty="0"/>
+          </a:p>
+        </p:txBody>
+      </p:sp>
+      <p:sp>
+        <p:nvSpPr>
+          <p:cNvPr id="16" name="Shape 14"/>
+          <p:cNvSpPr/>
+          <p:nvPr/>
+        </p:nvSpPr>
+        <p:spPr>
+          <a:xfrm>
+            <a:off x="6048756" y="1737360"/>
+            <a:ext cx="1191463" cy="566928"/>
           </a:xfrm>
           <a:prstGeom prst="chevron">
             <a:avLst/>
           </a:prstGeom>
           <a:solidFill>
-            <a:srgbClr val="226845"/>
+            <a:srgbClr val="1B5538"/>
           </a:solidFill>
           <a:ln w="19050">
             <a:solidFill>
@@ -8286,14 +8091,14 @@
       </p:sp>
       <p:sp>
         <p:nvSpPr>
-          <p:cNvPr id="22" name="Text 20"/>
-          <p:cNvSpPr/>
-          <p:nvPr/>
-        </p:nvSpPr>
-        <p:spPr>
-          <a:xfrm>
-            <a:off x="8703782" y="1828800"/>
-            <a:ext cx="1111649" cy="685800"/>
+          <p:cNvPr id="17" name="Text 15"/>
+          <p:cNvSpPr/>
+          <p:nvPr/>
+        </p:nvSpPr>
+        <p:spPr>
+          <a:xfrm>
+            <a:off x="6323076" y="1737360"/>
+            <a:ext cx="880567" cy="566928"/>
           </a:xfrm>
           <a:prstGeom prst="rect">
             <a:avLst/>
@@ -8309,7 +8114,7 @@
               <a:buNone/>
             </a:pPr>
             <a:r>
-              <a:rPr lang="en-US" sz="1250" dirty="0">
+              <a:rPr lang="en-US" sz="1050" dirty="0">
                 <a:solidFill>
                   <a:srgbClr val="FFFFFF"/>
                 </a:solidFill>
@@ -8317,67 +8122,28 @@
                 <a:ea typeface="Segoe UI Semibold" pitchFamily="34" charset="-122"/>
                 <a:cs typeface="Segoe UI Semibold" pitchFamily="34" charset="-120"/>
               </a:rPr>
-              <a:t>Act</a:t>
-            </a:r>
-            <a:endParaRPr lang="en-US" sz="1250" dirty="0"/>
-          </a:p>
-        </p:txBody>
-      </p:sp>
-      <p:sp>
-        <p:nvSpPr>
-          <p:cNvPr id="23" name="Text 21"/>
-          <p:cNvSpPr/>
-          <p:nvPr/>
-        </p:nvSpPr>
-        <p:spPr>
-          <a:xfrm>
-            <a:off x="8484326" y="2651760"/>
-            <a:ext cx="1449977" cy="914400"/>
-          </a:xfrm>
-          <a:prstGeom prst="rect">
-            <a:avLst/>
-          </a:prstGeom>
-          <a:noFill/>
-          <a:ln/>
-        </p:spPr>
-        <p:txBody>
-          <a:bodyPr wrap="square" lIns="0" tIns="0" rIns="0" bIns="0" rtlCol="0" anchor="t"/>
-          <a:lstStyle/>
-          <a:p>
-            <a:pPr indent="0" marL="0">
-              <a:buNone/>
-            </a:pPr>
-            <a:r>
-              <a:rPr lang="en-US" sz="1200" dirty="0">
-                <a:solidFill>
-                  <a:srgbClr val="56615A"/>
-                </a:solidFill>
-                <a:latin typeface="Segoe UI" pitchFamily="34" charset="0"/>
-                <a:ea typeface="Segoe UI" pitchFamily="34" charset="-122"/>
-                <a:cs typeface="Segoe UI" pitchFamily="34" charset="-120"/>
-              </a:rPr>
-              <a:t>The farmer accepts, ignores or checks first</a:t>
-            </a:r>
-            <a:endParaRPr lang="en-US" sz="1200" dirty="0"/>
-          </a:p>
-        </p:txBody>
-      </p:sp>
-      <p:sp>
-        <p:nvSpPr>
-          <p:cNvPr id="24" name="Shape 22"/>
-          <p:cNvSpPr/>
-          <p:nvPr/>
-        </p:nvSpPr>
-        <p:spPr>
-          <a:xfrm>
-            <a:off x="9961735" y="1828800"/>
-            <a:ext cx="1678577" cy="685800"/>
+              <a:t>Market</a:t>
+            </a:r>
+            <a:endParaRPr lang="en-US" sz="1050" dirty="0"/>
+          </a:p>
+        </p:txBody>
+      </p:sp>
+      <p:sp>
+        <p:nvSpPr>
+          <p:cNvPr id="18" name="Shape 16"/>
+          <p:cNvSpPr/>
+          <p:nvPr/>
+        </p:nvSpPr>
+        <p:spPr>
+          <a:xfrm>
+            <a:off x="7148779" y="1737360"/>
+            <a:ext cx="1191463" cy="566928"/>
           </a:xfrm>
           <a:prstGeom prst="chevron">
             <a:avLst/>
           </a:prstGeom>
           <a:solidFill>
-            <a:srgbClr val="226845"/>
+            <a:srgbClr val="1B5538"/>
           </a:solidFill>
           <a:ln w="19050">
             <a:solidFill>
@@ -8389,14 +8155,14 @@
       </p:sp>
       <p:sp>
         <p:nvSpPr>
-          <p:cNvPr id="25" name="Text 23"/>
-          <p:cNvSpPr/>
-          <p:nvPr/>
-        </p:nvSpPr>
-        <p:spPr>
-          <a:xfrm>
-            <a:off x="10272631" y="1828800"/>
-            <a:ext cx="1111649" cy="685800"/>
+          <p:cNvPr id="19" name="Text 17"/>
+          <p:cNvSpPr/>
+          <p:nvPr/>
+        </p:nvSpPr>
+        <p:spPr>
+          <a:xfrm>
+            <a:off x="7423099" y="1737360"/>
+            <a:ext cx="880567" cy="566928"/>
           </a:xfrm>
           <a:prstGeom prst="rect">
             <a:avLst/>
@@ -8412,7 +8178,7 @@
               <a:buNone/>
             </a:pPr>
             <a:r>
-              <a:rPr lang="en-US" sz="1250" dirty="0">
+              <a:rPr lang="en-US" sz="1050" dirty="0">
                 <a:solidFill>
                   <a:srgbClr val="FFFFFF"/>
                 </a:solidFill>
@@ -8420,9 +8186,201 @@
                 <a:ea typeface="Segoe UI Semibold" pitchFamily="34" charset="-122"/>
                 <a:cs typeface="Segoe UI Semibold" pitchFamily="34" charset="-120"/>
               </a:rPr>
-              <a:t>Measure</a:t>
-            </a:r>
-            <a:endParaRPr lang="en-US" sz="1250" dirty="0"/>
+              <a:t>Plan</a:t>
+            </a:r>
+            <a:endParaRPr lang="en-US" sz="1050" dirty="0"/>
+          </a:p>
+        </p:txBody>
+      </p:sp>
+      <p:sp>
+        <p:nvSpPr>
+          <p:cNvPr id="20" name="Shape 18"/>
+          <p:cNvSpPr/>
+          <p:nvPr/>
+        </p:nvSpPr>
+        <p:spPr>
+          <a:xfrm>
+            <a:off x="8248802" y="1737360"/>
+            <a:ext cx="1191463" cy="566928"/>
+          </a:xfrm>
+          <a:prstGeom prst="chevron">
+            <a:avLst/>
+          </a:prstGeom>
+          <a:solidFill>
+            <a:srgbClr val="1B5538"/>
+          </a:solidFill>
+          <a:ln w="19050">
+            <a:solidFill>
+              <a:srgbClr val="F6F6F3"/>
+            </a:solidFill>
+            <a:prstDash val="solid"/>
+          </a:ln>
+        </p:spPr>
+      </p:sp>
+      <p:sp>
+        <p:nvSpPr>
+          <p:cNvPr id="21" name="Text 19"/>
+          <p:cNvSpPr/>
+          <p:nvPr/>
+        </p:nvSpPr>
+        <p:spPr>
+          <a:xfrm>
+            <a:off x="8523122" y="1737360"/>
+            <a:ext cx="880567" cy="566928"/>
+          </a:xfrm>
+          <a:prstGeom prst="rect">
+            <a:avLst/>
+          </a:prstGeom>
+          <a:noFill/>
+          <a:ln/>
+        </p:spPr>
+        <p:txBody>
+          <a:bodyPr wrap="square" lIns="0" tIns="0" rIns="0" bIns="0" rtlCol="0" anchor="ctr"/>
+          <a:lstStyle/>
+          <a:p>
+            <a:pPr algn="ctr" indent="0" marL="0">
+              <a:buNone/>
+            </a:pPr>
+            <a:r>
+              <a:rPr lang="en-US" sz="1050" dirty="0">
+                <a:solidFill>
+                  <a:srgbClr val="FFFFFF"/>
+                </a:solidFill>
+                <a:latin typeface="Segoe UI Semibold" pitchFamily="34" charset="0"/>
+                <a:ea typeface="Segoe UI Semibold" pitchFamily="34" charset="-122"/>
+                <a:cs typeface="Segoe UI Semibold" pitchFamily="34" charset="-120"/>
+              </a:rPr>
+              <a:t>Resources</a:t>
+            </a:r>
+            <a:endParaRPr lang="en-US" sz="1050" dirty="0"/>
+          </a:p>
+        </p:txBody>
+      </p:sp>
+      <p:sp>
+        <p:nvSpPr>
+          <p:cNvPr id="22" name="Shape 20"/>
+          <p:cNvSpPr/>
+          <p:nvPr/>
+        </p:nvSpPr>
+        <p:spPr>
+          <a:xfrm>
+            <a:off x="9348826" y="1737360"/>
+            <a:ext cx="1191463" cy="566928"/>
+          </a:xfrm>
+          <a:prstGeom prst="chevron">
+            <a:avLst/>
+          </a:prstGeom>
+          <a:solidFill>
+            <a:srgbClr val="0F6A9C"/>
+          </a:solidFill>
+          <a:ln w="19050">
+            <a:solidFill>
+              <a:srgbClr val="F6F6F3"/>
+            </a:solidFill>
+            <a:prstDash val="solid"/>
+          </a:ln>
+        </p:spPr>
+      </p:sp>
+      <p:sp>
+        <p:nvSpPr>
+          <p:cNvPr id="23" name="Text 21"/>
+          <p:cNvSpPr/>
+          <p:nvPr/>
+        </p:nvSpPr>
+        <p:spPr>
+          <a:xfrm>
+            <a:off x="9623146" y="1737360"/>
+            <a:ext cx="880567" cy="566928"/>
+          </a:xfrm>
+          <a:prstGeom prst="rect">
+            <a:avLst/>
+          </a:prstGeom>
+          <a:noFill/>
+          <a:ln/>
+        </p:spPr>
+        <p:txBody>
+          <a:bodyPr wrap="square" lIns="0" tIns="0" rIns="0" bIns="0" rtlCol="0" anchor="ctr"/>
+          <a:lstStyle/>
+          <a:p>
+            <a:pPr algn="ctr" indent="0" marL="0">
+              <a:buNone/>
+            </a:pPr>
+            <a:r>
+              <a:rPr lang="en-US" sz="1050" dirty="0">
+                <a:solidFill>
+                  <a:srgbClr val="FFFFFF"/>
+                </a:solidFill>
+                <a:latin typeface="Segoe UI Semibold" pitchFamily="34" charset="0"/>
+                <a:ea typeface="Segoe UI Semibold" pitchFamily="34" charset="-122"/>
+                <a:cs typeface="Segoe UI Semibold" pitchFamily="34" charset="-120"/>
+              </a:rPr>
+              <a:t>Harvest</a:t>
+            </a:r>
+            <a:endParaRPr lang="en-US" sz="1050" dirty="0"/>
+          </a:p>
+        </p:txBody>
+      </p:sp>
+      <p:sp>
+        <p:nvSpPr>
+          <p:cNvPr id="24" name="Shape 22"/>
+          <p:cNvSpPr/>
+          <p:nvPr/>
+        </p:nvSpPr>
+        <p:spPr>
+          <a:xfrm>
+            <a:off x="10448849" y="1737360"/>
+            <a:ext cx="1191463" cy="566928"/>
+          </a:xfrm>
+          <a:prstGeom prst="chevron">
+            <a:avLst/>
+          </a:prstGeom>
+          <a:solidFill>
+            <a:srgbClr val="0F6A9C"/>
+          </a:solidFill>
+          <a:ln w="19050">
+            <a:solidFill>
+              <a:srgbClr val="F6F6F3"/>
+            </a:solidFill>
+            <a:prstDash val="solid"/>
+          </a:ln>
+        </p:spPr>
+      </p:sp>
+      <p:sp>
+        <p:nvSpPr>
+          <p:cNvPr id="25" name="Text 23"/>
+          <p:cNvSpPr/>
+          <p:nvPr/>
+        </p:nvSpPr>
+        <p:spPr>
+          <a:xfrm>
+            <a:off x="10723169" y="1737360"/>
+            <a:ext cx="880567" cy="566928"/>
+          </a:xfrm>
+          <a:prstGeom prst="rect">
+            <a:avLst/>
+          </a:prstGeom>
+          <a:noFill/>
+          <a:ln/>
+        </p:spPr>
+        <p:txBody>
+          <a:bodyPr wrap="square" lIns="0" tIns="0" rIns="0" bIns="0" rtlCol="0" anchor="ctr"/>
+          <a:lstStyle/>
+          <a:p>
+            <a:pPr algn="ctr" indent="0" marL="0">
+              <a:buNone/>
+            </a:pPr>
+            <a:r>
+              <a:rPr lang="en-US" sz="1050" dirty="0">
+                <a:solidFill>
+                  <a:srgbClr val="FFFFFF"/>
+                </a:solidFill>
+                <a:latin typeface="Segoe UI Semibold" pitchFamily="34" charset="0"/>
+                <a:ea typeface="Segoe UI Semibold" pitchFamily="34" charset="-122"/>
+                <a:cs typeface="Segoe UI Semibold" pitchFamily="34" charset="-120"/>
+              </a:rPr>
+              <a:t>Buyer</a:t>
+            </a:r>
+            <a:endParaRPr lang="en-US" sz="1050" dirty="0"/>
           </a:p>
         </p:txBody>
       </p:sp>
@@ -8434,8 +8392,106 @@
         </p:nvSpPr>
         <p:spPr>
           <a:xfrm>
-            <a:off x="10053175" y="2651760"/>
-            <a:ext cx="1449977" cy="914400"/>
+            <a:off x="548640" y="2606040"/>
+            <a:ext cx="5486400" cy="274320"/>
+          </a:xfrm>
+          <a:prstGeom prst="rect">
+            <a:avLst/>
+          </a:prstGeom>
+          <a:noFill/>
+          <a:ln/>
+        </p:spPr>
+        <p:txBody>
+          <a:bodyPr wrap="square" lIns="0" tIns="0" rIns="0" bIns="0" rtlCol="0" anchor="ctr"/>
+          <a:lstStyle/>
+          <a:p>
+            <a:pPr indent="0" marL="0">
+              <a:buNone/>
+            </a:pPr>
+            <a:r>
+              <a:rPr lang="en-US" sz="1000" spc="200" kern="0" dirty="0">
+                <a:solidFill>
+                  <a:srgbClr val="226845"/>
+                </a:solidFill>
+                <a:latin typeface="Segoe UI Semibold" pitchFamily="34" charset="0"/>
+                <a:ea typeface="Segoe UI Semibold" pitchFamily="34" charset="-122"/>
+                <a:cs typeface="Segoe UI Semibold" pitchFamily="34" charset="-120"/>
+              </a:rPr>
+              <a:t>SPANDANA'S SEASON IN THE PROTOTYPE</a:t>
+            </a:r>
+            <a:endParaRPr lang="en-US" sz="1000" dirty="0"/>
+          </a:p>
+        </p:txBody>
+      </p:sp>
+      <p:sp>
+        <p:nvSpPr>
+          <p:cNvPr id="27" name="Shape 25"/>
+          <p:cNvSpPr/>
+          <p:nvPr/>
+        </p:nvSpPr>
+        <p:spPr>
+          <a:xfrm>
+            <a:off x="548640" y="3008376"/>
+            <a:ext cx="45720" cy="603504"/>
+          </a:xfrm>
+          <a:prstGeom prst="rect">
+            <a:avLst/>
+          </a:prstGeom>
+          <a:solidFill>
+            <a:srgbClr val="1B5538"/>
+          </a:solidFill>
+          <a:ln/>
+        </p:spPr>
+      </p:sp>
+      <p:sp>
+        <p:nvSpPr>
+          <p:cNvPr id="28" name="Text 26"/>
+          <p:cNvSpPr/>
+          <p:nvPr/>
+        </p:nvSpPr>
+        <p:spPr>
+          <a:xfrm>
+            <a:off x="731520" y="2971800"/>
+            <a:ext cx="4754880" cy="274320"/>
+          </a:xfrm>
+          <a:prstGeom prst="rect">
+            <a:avLst/>
+          </a:prstGeom>
+          <a:noFill/>
+          <a:ln/>
+        </p:spPr>
+        <p:txBody>
+          <a:bodyPr wrap="square" lIns="0" tIns="0" rIns="0" bIns="0" rtlCol="0" anchor="ctr"/>
+          <a:lstStyle/>
+          <a:p>
+            <a:pPr indent="0" marL="0">
+              <a:buNone/>
+            </a:pPr>
+            <a:r>
+              <a:rPr lang="en-US" sz="1400" dirty="0">
+                <a:solidFill>
+                  <a:srgbClr val="17201B"/>
+                </a:solidFill>
+                <a:latin typeface="Segoe UI Semibold" pitchFamily="34" charset="0"/>
+                <a:ea typeface="Segoe UI Semibold" pitchFamily="34" charset="-122"/>
+                <a:cs typeface="Segoe UI Semibold" pitchFamily="34" charset="-120"/>
+              </a:rPr>
+              <a:t>Farm &amp; goal</a:t>
+            </a:r>
+            <a:endParaRPr lang="en-US" sz="1400" dirty="0"/>
+          </a:p>
+        </p:txBody>
+      </p:sp>
+      <p:sp>
+        <p:nvSpPr>
+          <p:cNvPr id="29" name="Text 27"/>
+          <p:cNvSpPr/>
+          <p:nvPr/>
+        </p:nvSpPr>
+        <p:spPr>
+          <a:xfrm>
+            <a:off x="731520" y="3246120"/>
+            <a:ext cx="4754880" cy="457200"/>
           </a:xfrm>
           <a:prstGeom prst="rect">
             <a:avLst/>
@@ -8451,7 +8507,7 @@
               <a:buNone/>
             </a:pPr>
             <a:r>
-              <a:rPr lang="en-US" sz="1200" dirty="0">
+              <a:rPr lang="en-US" sz="1250" dirty="0">
                 <a:solidFill>
                   <a:srgbClr val="56615A"/>
                 </a:solidFill>
@@ -8459,83 +8515,140 @@
                 <a:ea typeface="Segoe UI" pitchFamily="34" charset="-122"/>
                 <a:cs typeface="Segoe UI" pitchFamily="34" charset="-120"/>
               </a:rPr>
-              <a:t>Water, energy, inputs, loss and prices</a:t>
-            </a:r>
-            <a:endParaRPr lang="en-US" sz="1200" dirty="0"/>
-          </a:p>
-        </p:txBody>
-      </p:sp>
-      <p:sp>
-        <p:nvSpPr>
-          <p:cNvPr id="27" name="Text 25"/>
+              <a:t>1 acre near Chamarajanagara, red soil, drip, ₹1,50,000 to invest.</a:t>
+            </a:r>
+            <a:endParaRPr lang="en-US" sz="1250" dirty="0"/>
+          </a:p>
+        </p:txBody>
+      </p:sp>
+      <p:sp>
+        <p:nvSpPr>
+          <p:cNvPr id="30" name="Shape 28"/>
           <p:cNvSpPr/>
           <p:nvPr/>
         </p:nvSpPr>
         <p:spPr>
           <a:xfrm>
             <a:off x="548640" y="3794760"/>
-            <a:ext cx="5486400" cy="274320"/>
-          </a:xfrm>
-          <a:prstGeom prst="rect">
-            <a:avLst/>
-          </a:prstGeom>
-          <a:noFill/>
-          <a:ln/>
-        </p:spPr>
-        <p:txBody>
-          <a:bodyPr wrap="square" lIns="0" tIns="0" rIns="0" bIns="0" rtlCol="0" anchor="ctr"/>
-          <a:lstStyle/>
-          <a:p>
-            <a:pPr indent="0" marL="0">
-              <a:buNone/>
-            </a:pPr>
-            <a:r>
-              <a:rPr lang="en-US" sz="1000" spc="200" kern="0" dirty="0">
-                <a:solidFill>
-                  <a:srgbClr val="0F6A9C"/>
+            <a:ext cx="45720" cy="603504"/>
+          </a:xfrm>
+          <a:prstGeom prst="rect">
+            <a:avLst/>
+          </a:prstGeom>
+          <a:solidFill>
+            <a:srgbClr val="1B5538"/>
+          </a:solidFill>
+          <a:ln/>
+        </p:spPr>
+      </p:sp>
+      <p:sp>
+        <p:nvSpPr>
+          <p:cNvPr id="31" name="Text 29"/>
+          <p:cNvSpPr/>
+          <p:nvPr/>
+        </p:nvSpPr>
+        <p:spPr>
+          <a:xfrm>
+            <a:off x="731520" y="3758184"/>
+            <a:ext cx="4754880" cy="274320"/>
+          </a:xfrm>
+          <a:prstGeom prst="rect">
+            <a:avLst/>
+          </a:prstGeom>
+          <a:noFill/>
+          <a:ln/>
+        </p:spPr>
+        <p:txBody>
+          <a:bodyPr wrap="square" lIns="0" tIns="0" rIns="0" bIns="0" rtlCol="0" anchor="ctr"/>
+          <a:lstStyle/>
+          <a:p>
+            <a:pPr indent="0" marL="0">
+              <a:buNone/>
+            </a:pPr>
+            <a:r>
+              <a:rPr lang="en-US" sz="1400" dirty="0">
+                <a:solidFill>
+                  <a:srgbClr val="17201B"/>
                 </a:solidFill>
                 <a:latin typeface="Segoe UI Semibold" pitchFamily="34" charset="0"/>
                 <a:ea typeface="Segoe UI Semibold" pitchFamily="34" charset="-122"/>
                 <a:cs typeface="Segoe UI Semibold" pitchFamily="34" charset="-120"/>
               </a:rPr>
-              <a:t>ONE EXAMPLE FROM THE PROTOTYPE</a:t>
-            </a:r>
-            <a:endParaRPr lang="en-US" sz="1000" dirty="0"/>
-          </a:p>
-        </p:txBody>
-      </p:sp>
-      <p:sp>
-        <p:nvSpPr>
-          <p:cNvPr id="28" name="Shape 26"/>
-          <p:cNvSpPr/>
-          <p:nvPr/>
-        </p:nvSpPr>
-        <p:spPr>
-          <a:xfrm>
-            <a:off x="548640" y="4160520"/>
-            <a:ext cx="2606040" cy="1783080"/>
-          </a:xfrm>
-          <a:prstGeom prst="roundRect">
-            <a:avLst>
-              <a:gd name="adj" fmla="val 4103"/>
-            </a:avLst>
+              <a:t>Crop &amp; method</a:t>
+            </a:r>
+            <a:endParaRPr lang="en-US" sz="1400" dirty="0"/>
+          </a:p>
+        </p:txBody>
+      </p:sp>
+      <p:sp>
+        <p:nvSpPr>
+          <p:cNvPr id="32" name="Text 30"/>
+          <p:cNvSpPr/>
+          <p:nvPr/>
+        </p:nvSpPr>
+        <p:spPr>
+          <a:xfrm>
+            <a:off x="731520" y="4032504"/>
+            <a:ext cx="4754880" cy="457200"/>
+          </a:xfrm>
+          <a:prstGeom prst="rect">
+            <a:avLst/>
+          </a:prstGeom>
+          <a:noFill/>
+          <a:ln/>
+        </p:spPr>
+        <p:txBody>
+          <a:bodyPr wrap="square" lIns="0" tIns="0" rIns="0" bIns="0" rtlCol="0" anchor="t"/>
+          <a:lstStyle/>
+          <a:p>
+            <a:pPr indent="0" marL="0">
+              <a:buNone/>
+            </a:pPr>
+            <a:r>
+              <a:rPr lang="en-US" sz="1250" dirty="0">
+                <a:solidFill>
+                  <a:srgbClr val="56615A"/>
+                </a:solidFill>
+                <a:latin typeface="Segoe UI" pitchFamily="34" charset="0"/>
+                <a:ea typeface="Segoe UI" pitchFamily="34" charset="-122"/>
+                <a:cs typeface="Segoe UI" pitchFamily="34" charset="-120"/>
+              </a:rPr>
+              <a:t>Tomato is the best match, with the reasons shown. Precision farming suits her drip and solar.</a:t>
+            </a:r>
+            <a:endParaRPr lang="en-US" sz="1250" dirty="0"/>
+          </a:p>
+        </p:txBody>
+      </p:sp>
+      <p:sp>
+        <p:nvSpPr>
+          <p:cNvPr id="33" name="Shape 31"/>
+          <p:cNvSpPr/>
+          <p:nvPr/>
+        </p:nvSpPr>
+        <p:spPr>
+          <a:xfrm>
+            <a:off x="548640" y="4581144"/>
+            <a:ext cx="45720" cy="603504"/>
+          </a:xfrm>
+          <a:prstGeom prst="rect">
+            <a:avLst/>
           </a:prstGeom>
           <a:solidFill>
-            <a:srgbClr val="E7F1F8"/>
+            <a:srgbClr val="1B5538"/>
           </a:solidFill>
           <a:ln/>
         </p:spPr>
       </p:sp>
       <p:sp>
         <p:nvSpPr>
-          <p:cNvPr id="29" name="Text 27"/>
-          <p:cNvSpPr/>
-          <p:nvPr/>
-        </p:nvSpPr>
-        <p:spPr>
-          <a:xfrm>
-            <a:off x="731520" y="4315968"/>
-            <a:ext cx="2286000" cy="274320"/>
+          <p:cNvPr id="34" name="Text 32"/>
+          <p:cNvSpPr/>
+          <p:nvPr/>
+        </p:nvSpPr>
+        <p:spPr>
+          <a:xfrm>
+            <a:off x="731520" y="4544568"/>
+            <a:ext cx="4754880" cy="274320"/>
           </a:xfrm>
           <a:prstGeom prst="rect">
             <a:avLst/>
@@ -8553,13 +8666,13 @@
             <a:r>
               <a:rPr lang="en-US" sz="1400" dirty="0">
                 <a:solidFill>
-                  <a:srgbClr val="0F6A9C"/>
+                  <a:srgbClr val="17201B"/>
                 </a:solidFill>
                 <a:latin typeface="Segoe UI Semibold" pitchFamily="34" charset="0"/>
                 <a:ea typeface="Segoe UI Semibold" pitchFamily="34" charset="-122"/>
                 <a:cs typeface="Segoe UI Semibold" pitchFamily="34" charset="-120"/>
               </a:rPr>
-              <a:t>Signal</a:t>
+              <a:t>Investment &amp; plan</a:t>
             </a:r>
             <a:endParaRPr lang="en-US" sz="1400" dirty="0"/>
           </a:p>
@@ -8567,14 +8680,14 @@
       </p:sp>
       <p:sp>
         <p:nvSpPr>
-          <p:cNvPr id="30" name="Text 28"/>
-          <p:cNvSpPr/>
-          <p:nvPr/>
-        </p:nvSpPr>
-        <p:spPr>
-          <a:xfrm>
-            <a:off x="731520" y="4663440"/>
-            <a:ext cx="2286000" cy="1188720"/>
+          <p:cNvPr id="35" name="Text 33"/>
+          <p:cNvSpPr/>
+          <p:nvPr/>
+        </p:nvSpPr>
+        <p:spPr>
+          <a:xfrm>
+            <a:off x="731520" y="4818888"/>
+            <a:ext cx="4754880" cy="457200"/>
           </a:xfrm>
           <a:prstGeom prst="rect">
             <a:avLst/>
@@ -8590,434 +8703,212 @@
               <a:buNone/>
             </a:pPr>
             <a:r>
-              <a:rPr lang="en-US" sz="1300" dirty="0">
-                <a:solidFill>
-                  <a:srgbClr val="17201B"/>
+              <a:rPr lang="en-US" sz="1250" dirty="0">
+                <a:solidFill>
+                  <a:srgbClr val="56615A"/>
                 </a:solidFill>
                 <a:latin typeface="Segoe UI" pitchFamily="34" charset="0"/>
                 <a:ea typeface="Segoe UI" pitchFamily="34" charset="-122"/>
                 <a:cs typeface="Segoe UI" pitchFamily="34" charset="-120"/>
               </a:rPr>
-              <a:t>Rain 82% likely from 6:30 pm. Field 1 soil moisture 64%; tomato needs at least 55%.</a:t>
-            </a:r>
-            <a:endParaRPr lang="en-US" sz="1300" dirty="0"/>
-          </a:p>
-        </p:txBody>
-      </p:sp>
-      <p:sp>
-        <p:nvSpPr>
-          <p:cNvPr id="31" name="Text 29"/>
-          <p:cNvSpPr/>
-          <p:nvPr/>
-        </p:nvSpPr>
-        <p:spPr>
-          <a:xfrm>
-            <a:off x="3136392" y="4800600"/>
-            <a:ext cx="274320" cy="365760"/>
-          </a:xfrm>
-          <a:prstGeom prst="rect">
-            <a:avLst/>
-          </a:prstGeom>
-          <a:noFill/>
-          <a:ln/>
-        </p:spPr>
-        <p:txBody>
-          <a:bodyPr wrap="square" lIns="0" tIns="0" rIns="0" bIns="0" rtlCol="0" anchor="ctr"/>
-          <a:lstStyle/>
-          <a:p>
-            <a:pPr algn="ctr" indent="0" marL="0">
-              <a:buNone/>
-            </a:pPr>
-            <a:r>
-              <a:rPr lang="en-US" sz="1800" dirty="0">
-                <a:solidFill>
-                  <a:srgbClr val="0F6A9C"/>
+              <a:t>₹1,50,000 split across ten costs; tractor and sprayer rented, not bought. First harvest around 4 October.</a:t>
+            </a:r>
+            <a:endParaRPr lang="en-US" sz="1250" dirty="0"/>
+          </a:p>
+        </p:txBody>
+      </p:sp>
+      <p:sp>
+        <p:nvSpPr>
+          <p:cNvPr id="36" name="Shape 34"/>
+          <p:cNvSpPr/>
+          <p:nvPr/>
+        </p:nvSpPr>
+        <p:spPr>
+          <a:xfrm>
+            <a:off x="548640" y="5367528"/>
+            <a:ext cx="45720" cy="603504"/>
+          </a:xfrm>
+          <a:prstGeom prst="rect">
+            <a:avLst/>
+          </a:prstGeom>
+          <a:solidFill>
+            <a:srgbClr val="0F6A9C"/>
+          </a:solidFill>
+          <a:ln/>
+        </p:spPr>
+      </p:sp>
+      <p:sp>
+        <p:nvSpPr>
+          <p:cNvPr id="37" name="Text 35"/>
+          <p:cNvSpPr/>
+          <p:nvPr/>
+        </p:nvSpPr>
+        <p:spPr>
+          <a:xfrm>
+            <a:off x="731520" y="5330952"/>
+            <a:ext cx="4754880" cy="274320"/>
+          </a:xfrm>
+          <a:prstGeom prst="rect">
+            <a:avLst/>
+          </a:prstGeom>
+          <a:noFill/>
+          <a:ln/>
+        </p:spPr>
+        <p:txBody>
+          <a:bodyPr wrap="square" lIns="0" tIns="0" rIns="0" bIns="0" rtlCol="0" anchor="ctr"/>
+          <a:lstStyle/>
+          <a:p>
+            <a:pPr indent="0" marL="0">
+              <a:buNone/>
+            </a:pPr>
+            <a:r>
+              <a:rPr lang="en-US" sz="1400" dirty="0">
+                <a:solidFill>
+                  <a:srgbClr val="17201B"/>
+                </a:solidFill>
+                <a:latin typeface="Segoe UI Semibold" pitchFamily="34" charset="0"/>
+                <a:ea typeface="Segoe UI Semibold" pitchFamily="34" charset="-122"/>
+                <a:cs typeface="Segoe UI Semibold" pitchFamily="34" charset="-120"/>
+              </a:rPr>
+              <a:t>Harvest &amp; buyer</a:t>
+            </a:r>
+            <a:endParaRPr lang="en-US" sz="1400" dirty="0"/>
+          </a:p>
+        </p:txBody>
+      </p:sp>
+      <p:sp>
+        <p:nvSpPr>
+          <p:cNvPr id="38" name="Text 36"/>
+          <p:cNvSpPr/>
+          <p:nvPr/>
+        </p:nvSpPr>
+        <p:spPr>
+          <a:xfrm>
+            <a:off x="731520" y="5605272"/>
+            <a:ext cx="4754880" cy="457200"/>
+          </a:xfrm>
+          <a:prstGeom prst="rect">
+            <a:avLst/>
+          </a:prstGeom>
+          <a:noFill/>
+          <a:ln/>
+        </p:spPr>
+        <p:txBody>
+          <a:bodyPr wrap="square" lIns="0" tIns="0" rIns="0" bIns="0" rtlCol="0" anchor="t"/>
+          <a:lstStyle/>
+          <a:p>
+            <a:pPr indent="0" marL="0">
+              <a:buNone/>
+            </a:pPr>
+            <a:r>
+              <a:rPr lang="en-US" sz="1250" dirty="0">
+                <a:solidFill>
+                  <a:srgbClr val="56615A"/>
                 </a:solidFill>
                 <a:latin typeface="Segoe UI" pitchFamily="34" charset="0"/>
                 <a:ea typeface="Segoe UI" pitchFamily="34" charset="-122"/>
                 <a:cs typeface="Segoe UI" pitchFamily="34" charset="-120"/>
               </a:rPr>
-              <a:t>→</a:t>
-            </a:r>
-            <a:endParaRPr lang="en-US" sz="1800" dirty="0"/>
-          </a:p>
-        </p:txBody>
-      </p:sp>
-      <p:sp>
-        <p:nvSpPr>
-          <p:cNvPr id="32" name="Shape 30"/>
-          <p:cNvSpPr/>
-          <p:nvPr/>
-        </p:nvSpPr>
-        <p:spPr>
-          <a:xfrm>
-            <a:off x="3383280" y="4160520"/>
-            <a:ext cx="2606040" cy="1783080"/>
+              <a:t>2,000 kg of Grade A tomato listed. She chooses what buyers see; a buyer requests, she decides.</a:t>
+            </a:r>
+            <a:endParaRPr lang="en-US" sz="1250" dirty="0"/>
+          </a:p>
+        </p:txBody>
+      </p:sp>
+      <p:sp>
+        <p:nvSpPr>
+          <p:cNvPr id="39" name="Shape 37"/>
+          <p:cNvSpPr/>
+          <p:nvPr/>
+        </p:nvSpPr>
+        <p:spPr>
+          <a:xfrm>
+            <a:off x="5852160" y="2697480"/>
+            <a:ext cx="5806440" cy="2704798"/>
           </a:xfrm>
           <a:prstGeom prst="roundRect">
             <a:avLst>
-              <a:gd name="adj" fmla="val 4103"/>
+              <a:gd name="adj" fmla="val 2705"/>
             </a:avLst>
           </a:prstGeom>
           <a:solidFill>
-            <a:srgbClr val="E7F1F8"/>
+            <a:srgbClr val="FFFFFF"/>
           </a:solidFill>
-          <a:ln/>
-        </p:spPr>
-      </p:sp>
-      <p:sp>
-        <p:nvSpPr>
-          <p:cNvPr id="33" name="Text 31"/>
-          <p:cNvSpPr/>
-          <p:nvPr/>
-        </p:nvSpPr>
-        <p:spPr>
-          <a:xfrm>
-            <a:off x="3566160" y="4315968"/>
-            <a:ext cx="2286000" cy="274320"/>
-          </a:xfrm>
-          <a:prstGeom prst="rect">
-            <a:avLst/>
-          </a:prstGeom>
-          <a:noFill/>
-          <a:ln/>
-        </p:spPr>
-        <p:txBody>
-          <a:bodyPr wrap="square" lIns="0" tIns="0" rIns="0" bIns="0" rtlCol="0" anchor="ctr"/>
-          <a:lstStyle/>
-          <a:p>
-            <a:pPr indent="0" marL="0">
-              <a:buNone/>
-            </a:pPr>
-            <a:r>
-              <a:rPr lang="en-US" sz="1400" dirty="0">
-                <a:solidFill>
-                  <a:srgbClr val="0F6A9C"/>
-                </a:solidFill>
-                <a:latin typeface="Segoe UI Semibold" pitchFamily="34" charset="0"/>
-                <a:ea typeface="Segoe UI Semibold" pitchFamily="34" charset="-122"/>
-                <a:cs typeface="Segoe UI Semibold" pitchFamily="34" charset="-120"/>
-              </a:rPr>
-              <a:t>Suggestion</a:t>
-            </a:r>
-            <a:endParaRPr lang="en-US" sz="1400" dirty="0"/>
-          </a:p>
-        </p:txBody>
-      </p:sp>
-      <p:sp>
-        <p:nvSpPr>
-          <p:cNvPr id="34" name="Text 32"/>
-          <p:cNvSpPr/>
-          <p:nvPr/>
-        </p:nvSpPr>
-        <p:spPr>
-          <a:xfrm>
-            <a:off x="3566160" y="4663440"/>
-            <a:ext cx="2286000" cy="1188720"/>
-          </a:xfrm>
-          <a:prstGeom prst="rect">
-            <a:avLst/>
-          </a:prstGeom>
-          <a:noFill/>
-          <a:ln/>
-        </p:spPr>
-        <p:txBody>
-          <a:bodyPr wrap="square" lIns="0" tIns="0" rIns="0" bIns="0" rtlCol="0" anchor="t"/>
-          <a:lstStyle/>
-          <a:p>
-            <a:pPr indent="0" marL="0">
-              <a:buNone/>
-            </a:pPr>
-            <a:r>
-              <a:rPr lang="en-US" sz="1300" dirty="0">
-                <a:solidFill>
-                  <a:srgbClr val="17201B"/>
+          <a:ln w="9525">
+            <a:solidFill>
+              <a:srgbClr val="E3E5DF"/>
+            </a:solidFill>
+            <a:prstDash val="solid"/>
+          </a:ln>
+          <a:effectLst>
+            <a:outerShdw sx="100000" sy="100000" kx="0" ky="0" algn="bl" rotWithShape="0" blurRad="152400" dist="38100" dir="5400000">
+              <a:srgbClr val="17201B">
+                <a:alpha val="12000"/>
+              </a:srgbClr>
+            </a:outerShdw>
+          </a:effectLst>
+        </p:spPr>
+      </p:sp>
+      <p:pic>
+        <p:nvPicPr>
+          <p:cNvPr id="40" name="Image 0" descr="assets/plan-crop.png">    </p:cNvPr>
+          <p:cNvPicPr>
+            <a:picLocks noChangeAspect="1"/>
+          </p:cNvPicPr>
+          <p:nvPr/>
+        </p:nvPicPr>
+        <p:blipFill>
+          <a:blip r:embed="rId1"/>
+          <a:stretch>
+            <a:fillRect/>
+          </a:stretch>
+        </p:blipFill>
+        <p:spPr>
+          <a:xfrm>
+            <a:off x="5907024" y="2752344"/>
+            <a:ext cx="5696712" cy="2595070"/>
+          </a:xfrm>
+          <a:prstGeom prst="rect">
+            <a:avLst/>
+          </a:prstGeom>
+        </p:spPr>
+      </p:pic>
+      <p:sp>
+        <p:nvSpPr>
+          <p:cNvPr id="41" name="Text 38"/>
+          <p:cNvSpPr/>
+          <p:nvPr/>
+        </p:nvSpPr>
+        <p:spPr>
+          <a:xfrm>
+            <a:off x="5852160" y="5512006"/>
+            <a:ext cx="5806440" cy="274320"/>
+          </a:xfrm>
+          <a:prstGeom prst="rect">
+            <a:avLst/>
+          </a:prstGeom>
+          <a:noFill/>
+          <a:ln/>
+        </p:spPr>
+        <p:txBody>
+          <a:bodyPr wrap="square" lIns="0" tIns="0" rIns="0" bIns="0" rtlCol="0" anchor="ctr"/>
+          <a:lstStyle/>
+          <a:p>
+            <a:pPr indent="0" marL="0">
+              <a:buNone/>
+            </a:pPr>
+            <a:r>
+              <a:rPr lang="en-US" sz="1100" i="1" dirty="0">
+                <a:solidFill>
+                  <a:srgbClr val="636C65"/>
                 </a:solidFill>
                 <a:latin typeface="Segoe UI" pitchFamily="34" charset="0"/>
                 <a:ea typeface="Segoe UI" pitchFamily="34" charset="-122"/>
                 <a:cs typeface="Segoe UI" pitchFamily="34" charset="-120"/>
               </a:rPr>
-              <a:t>Consider delaying Field 1 irrigation by 24 hours, with the data shown.</a:t>
-            </a:r>
-            <a:endParaRPr lang="en-US" sz="1300" dirty="0"/>
-          </a:p>
-        </p:txBody>
-      </p:sp>
-      <p:sp>
-        <p:nvSpPr>
-          <p:cNvPr id="35" name="Text 33"/>
-          <p:cNvSpPr/>
-          <p:nvPr/>
-        </p:nvSpPr>
-        <p:spPr>
-          <a:xfrm>
-            <a:off x="5971032" y="4800600"/>
-            <a:ext cx="274320" cy="365760"/>
-          </a:xfrm>
-          <a:prstGeom prst="rect">
-            <a:avLst/>
-          </a:prstGeom>
-          <a:noFill/>
-          <a:ln/>
-        </p:spPr>
-        <p:txBody>
-          <a:bodyPr wrap="square" lIns="0" tIns="0" rIns="0" bIns="0" rtlCol="0" anchor="ctr"/>
-          <a:lstStyle/>
-          <a:p>
-            <a:pPr algn="ctr" indent="0" marL="0">
-              <a:buNone/>
-            </a:pPr>
-            <a:r>
-              <a:rPr lang="en-US" sz="1800" dirty="0">
-                <a:solidFill>
-                  <a:srgbClr val="0F6A9C"/>
-                </a:solidFill>
-                <a:latin typeface="Segoe UI" pitchFamily="34" charset="0"/>
-                <a:ea typeface="Segoe UI" pitchFamily="34" charset="-122"/>
-                <a:cs typeface="Segoe UI" pitchFamily="34" charset="-120"/>
-              </a:rPr>
-              <a:t>→</a:t>
-            </a:r>
-            <a:endParaRPr lang="en-US" sz="1800" dirty="0"/>
-          </a:p>
-        </p:txBody>
-      </p:sp>
-      <p:sp>
-        <p:nvSpPr>
-          <p:cNvPr id="36" name="Shape 34"/>
-          <p:cNvSpPr/>
-          <p:nvPr/>
-        </p:nvSpPr>
-        <p:spPr>
-          <a:xfrm>
-            <a:off x="6217920" y="4160520"/>
-            <a:ext cx="2606040" cy="1783080"/>
-          </a:xfrm>
-          <a:prstGeom prst="roundRect">
-            <a:avLst>
-              <a:gd name="adj" fmla="val 4103"/>
-            </a:avLst>
-          </a:prstGeom>
-          <a:solidFill>
-            <a:srgbClr val="E7F1F8"/>
-          </a:solidFill>
-          <a:ln/>
-        </p:spPr>
-      </p:sp>
-      <p:sp>
-        <p:nvSpPr>
-          <p:cNvPr id="37" name="Text 35"/>
-          <p:cNvSpPr/>
-          <p:nvPr/>
-        </p:nvSpPr>
-        <p:spPr>
-          <a:xfrm>
-            <a:off x="6400800" y="4315968"/>
-            <a:ext cx="2286000" cy="274320"/>
-          </a:xfrm>
-          <a:prstGeom prst="rect">
-            <a:avLst/>
-          </a:prstGeom>
-          <a:noFill/>
-          <a:ln/>
-        </p:spPr>
-        <p:txBody>
-          <a:bodyPr wrap="square" lIns="0" tIns="0" rIns="0" bIns="0" rtlCol="0" anchor="ctr"/>
-          <a:lstStyle/>
-          <a:p>
-            <a:pPr indent="0" marL="0">
-              <a:buNone/>
-            </a:pPr>
-            <a:r>
-              <a:rPr lang="en-US" sz="1400" dirty="0">
-                <a:solidFill>
-                  <a:srgbClr val="0F6A9C"/>
-                </a:solidFill>
-                <a:latin typeface="Segoe UI Semibold" pitchFamily="34" charset="0"/>
-                <a:ea typeface="Segoe UI Semibold" pitchFamily="34" charset="-122"/>
-                <a:cs typeface="Segoe UI Semibold" pitchFamily="34" charset="-120"/>
-              </a:rPr>
-              <a:t>Decision</a:t>
-            </a:r>
-            <a:endParaRPr lang="en-US" sz="1400" dirty="0"/>
-          </a:p>
-        </p:txBody>
-      </p:sp>
-      <p:sp>
-        <p:nvSpPr>
-          <p:cNvPr id="38" name="Text 36"/>
-          <p:cNvSpPr/>
-          <p:nvPr/>
-        </p:nvSpPr>
-        <p:spPr>
-          <a:xfrm>
-            <a:off x="6400800" y="4663440"/>
-            <a:ext cx="2286000" cy="1188720"/>
-          </a:xfrm>
-          <a:prstGeom prst="rect">
-            <a:avLst/>
-          </a:prstGeom>
-          <a:noFill/>
-          <a:ln/>
-        </p:spPr>
-        <p:txBody>
-          <a:bodyPr wrap="square" lIns="0" tIns="0" rIns="0" bIns="0" rtlCol="0" anchor="t"/>
-          <a:lstStyle/>
-          <a:p>
-            <a:pPr indent="0" marL="0">
-              <a:buNone/>
-            </a:pPr>
-            <a:r>
-              <a:rPr lang="en-US" sz="1300" dirty="0">
-                <a:solidFill>
-                  <a:srgbClr val="17201B"/>
-                </a:solidFill>
-                <a:latin typeface="Segoe UI" pitchFamily="34" charset="0"/>
-                <a:ea typeface="Segoe UI" pitchFamily="34" charset="-122"/>
-                <a:cs typeface="Segoe UI" pitchFamily="34" charset="-120"/>
-              </a:rPr>
-              <a:t>The farmer accepts. The schedule moves; one tap undoes it.</a:t>
-            </a:r>
-            <a:endParaRPr lang="en-US" sz="1300" dirty="0"/>
-          </a:p>
-        </p:txBody>
-      </p:sp>
-      <p:sp>
-        <p:nvSpPr>
-          <p:cNvPr id="39" name="Text 37"/>
-          <p:cNvSpPr/>
-          <p:nvPr/>
-        </p:nvSpPr>
-        <p:spPr>
-          <a:xfrm>
-            <a:off x="8805672" y="4800600"/>
-            <a:ext cx="274320" cy="365760"/>
-          </a:xfrm>
-          <a:prstGeom prst="rect">
-            <a:avLst/>
-          </a:prstGeom>
-          <a:noFill/>
-          <a:ln/>
-        </p:spPr>
-        <p:txBody>
-          <a:bodyPr wrap="square" lIns="0" tIns="0" rIns="0" bIns="0" rtlCol="0" anchor="ctr"/>
-          <a:lstStyle/>
-          <a:p>
-            <a:pPr algn="ctr" indent="0" marL="0">
-              <a:buNone/>
-            </a:pPr>
-            <a:r>
-              <a:rPr lang="en-US" sz="1800" dirty="0">
-                <a:solidFill>
-                  <a:srgbClr val="0F6A9C"/>
-                </a:solidFill>
-                <a:latin typeface="Segoe UI" pitchFamily="34" charset="0"/>
-                <a:ea typeface="Segoe UI" pitchFamily="34" charset="-122"/>
-                <a:cs typeface="Segoe UI" pitchFamily="34" charset="-120"/>
-              </a:rPr>
-              <a:t>→</a:t>
-            </a:r>
-            <a:endParaRPr lang="en-US" sz="1800" dirty="0"/>
-          </a:p>
-        </p:txBody>
-      </p:sp>
-      <p:sp>
-        <p:nvSpPr>
-          <p:cNvPr id="40" name="Shape 38"/>
-          <p:cNvSpPr/>
-          <p:nvPr/>
-        </p:nvSpPr>
-        <p:spPr>
-          <a:xfrm>
-            <a:off x="9052560" y="4160520"/>
-            <a:ext cx="2606040" cy="1783080"/>
-          </a:xfrm>
-          <a:prstGeom prst="roundRect">
-            <a:avLst>
-              <a:gd name="adj" fmla="val 4103"/>
-            </a:avLst>
-          </a:prstGeom>
-          <a:solidFill>
-            <a:srgbClr val="E7F1F8"/>
-          </a:solidFill>
-          <a:ln/>
-        </p:spPr>
-      </p:sp>
-      <p:sp>
-        <p:nvSpPr>
-          <p:cNvPr id="41" name="Text 39"/>
-          <p:cNvSpPr/>
-          <p:nvPr/>
-        </p:nvSpPr>
-        <p:spPr>
-          <a:xfrm>
-            <a:off x="9235440" y="4315968"/>
-            <a:ext cx="2286000" cy="274320"/>
-          </a:xfrm>
-          <a:prstGeom prst="rect">
-            <a:avLst/>
-          </a:prstGeom>
-          <a:noFill/>
-          <a:ln/>
-        </p:spPr>
-        <p:txBody>
-          <a:bodyPr wrap="square" lIns="0" tIns="0" rIns="0" bIns="0" rtlCol="0" anchor="ctr"/>
-          <a:lstStyle/>
-          <a:p>
-            <a:pPr indent="0" marL="0">
-              <a:buNone/>
-            </a:pPr>
-            <a:r>
-              <a:rPr lang="en-US" sz="1400" dirty="0">
-                <a:solidFill>
-                  <a:srgbClr val="0F6A9C"/>
-                </a:solidFill>
-                <a:latin typeface="Segoe UI Semibold" pitchFamily="34" charset="0"/>
-                <a:ea typeface="Segoe UI Semibold" pitchFamily="34" charset="-122"/>
-                <a:cs typeface="Segoe UI Semibold" pitchFamily="34" charset="-120"/>
-              </a:rPr>
-              <a:t>Measured</a:t>
-            </a:r>
-            <a:endParaRPr lang="en-US" sz="1400" dirty="0"/>
-          </a:p>
-        </p:txBody>
-      </p:sp>
-      <p:sp>
-        <p:nvSpPr>
-          <p:cNvPr id="42" name="Text 40"/>
-          <p:cNvSpPr/>
-          <p:nvPr/>
-        </p:nvSpPr>
-        <p:spPr>
-          <a:xfrm>
-            <a:off x="9235440" y="4663440"/>
-            <a:ext cx="2286000" cy="1188720"/>
-          </a:xfrm>
-          <a:prstGeom prst="rect">
-            <a:avLst/>
-          </a:prstGeom>
-          <a:noFill/>
-          <a:ln/>
-        </p:spPr>
-        <p:txBody>
-          <a:bodyPr wrap="square" lIns="0" tIns="0" rIns="0" bIns="0" rtlCol="0" anchor="t"/>
-          <a:lstStyle/>
-          <a:p>
-            <a:pPr indent="0" marL="0">
-              <a:buNone/>
-            </a:pPr>
-            <a:r>
-              <a:rPr lang="en-US" sz="1300" dirty="0">
-                <a:solidFill>
-                  <a:srgbClr val="17201B"/>
-                </a:solidFill>
-                <a:latin typeface="Segoe UI" pitchFamily="34" charset="0"/>
-                <a:ea typeface="Segoe UI" pitchFamily="34" charset="-122"/>
-                <a:cs typeface="Segoe UI" pitchFamily="34" charset="-120"/>
-              </a:rPr>
-              <a:t>About 36,000 L of water and 11 kWh of pumping avoided (indicative).</a:t>
-            </a:r>
-            <a:endParaRPr lang="en-US" sz="1300" dirty="0"/>
+              <a:t>Crop step: indicative ranges and the reasons behind the suggestion, never a guaranteed income</a:t>
+            </a:r>
+            <a:endParaRPr lang="en-US" sz="1100" dirty="0"/>
           </a:p>
         </p:txBody>
       </p:sp>
@@ -10185,7 +10076,7 @@
                 <a:ea typeface="Segoe UI Semibold" pitchFamily="34" charset="-122"/>
                 <a:cs typeface="Segoe UI Semibold" pitchFamily="34" charset="-120"/>
               </a:rPr>
-              <a:t>Six roles, one connected cluster</a:t>
+              <a:t>Seven roles, one connected cluster</a:t>
             </a:r>
             <a:endParaRPr lang="en-US" sz="3000" dirty="0"/>
           </a:p>
@@ -10277,24 +10168,24 @@
         </p:nvSpPr>
         <p:spPr>
           <a:xfrm>
-            <a:off x="548640" y="1737360"/>
-            <a:ext cx="4389120" cy="274320"/>
-          </a:xfrm>
-          <a:prstGeom prst="rect">
-            <a:avLst/>
-          </a:prstGeom>
-          <a:noFill/>
-          <a:ln/>
-        </p:spPr>
-        <p:txBody>
-          <a:bodyPr wrap="square" lIns="0" tIns="0" rIns="0" bIns="0" rtlCol="0" anchor="ctr"/>
-          <a:lstStyle/>
-          <a:p>
-            <a:pPr indent="0" marL="0">
-              <a:buNone/>
-            </a:pPr>
-            <a:r>
-              <a:rPr lang="en-US" sz="1500" dirty="0">
+            <a:off x="548640" y="1691640"/>
+            <a:ext cx="4389120" cy="256032"/>
+          </a:xfrm>
+          <a:prstGeom prst="rect">
+            <a:avLst/>
+          </a:prstGeom>
+          <a:noFill/>
+          <a:ln/>
+        </p:spPr>
+        <p:txBody>
+          <a:bodyPr wrap="square" lIns="0" tIns="0" rIns="0" bIns="0" rtlCol="0" anchor="ctr"/>
+          <a:lstStyle/>
+          <a:p>
+            <a:pPr indent="0" marL="0">
+              <a:buNone/>
+            </a:pPr>
+            <a:r>
+              <a:rPr lang="en-US" sz="1400" dirty="0">
                 <a:solidFill>
                   <a:srgbClr val="1B5538"/>
                 </a:solidFill>
@@ -10304,7 +10195,7 @@
               </a:rPr>
               <a:t>Farmer</a:t>
             </a:r>
-            <a:endParaRPr lang="en-US" sz="1500" dirty="0"/>
+            <a:endParaRPr lang="en-US" sz="1400" dirty="0"/>
           </a:p>
         </p:txBody>
       </p:sp>
@@ -10316,8 +10207,8 @@
         </p:nvSpPr>
         <p:spPr>
           <a:xfrm>
-            <a:off x="548640" y="2011680"/>
-            <a:ext cx="4389120" cy="411480"/>
+            <a:off x="548640" y="1947672"/>
+            <a:ext cx="4389120" cy="347472"/>
           </a:xfrm>
           <a:prstGeom prst="rect">
             <a:avLst/>
@@ -10333,7 +10224,7 @@
               <a:buNone/>
             </a:pPr>
             <a:r>
-              <a:rPr lang="en-US" sz="1250" dirty="0">
+              <a:rPr lang="en-US" sz="1200" dirty="0">
                 <a:solidFill>
                   <a:srgbClr val="17201B"/>
                 </a:solidFill>
@@ -10341,9 +10232,9 @@
                 <a:ea typeface="Segoe UI" pitchFamily="34" charset="-122"/>
                 <a:cs typeface="Segoe UI" pitchFamily="34" charset="-120"/>
               </a:rPr>
-              <a:t>Decisions with reasons; requests resources; lists harvests.</a:t>
-            </a:r>
-            <a:endParaRPr lang="en-US" sz="1250" dirty="0"/>
+              <a:t>Plans the season, requests resources, lists harvests.</a:t>
+            </a:r>
+            <a:endParaRPr lang="en-US" sz="1200" dirty="0"/>
           </a:p>
         </p:txBody>
       </p:sp>
@@ -10355,24 +10246,24 @@
         </p:nvSpPr>
         <p:spPr>
           <a:xfrm>
-            <a:off x="548640" y="2468880"/>
-            <a:ext cx="4389120" cy="274320"/>
-          </a:xfrm>
-          <a:prstGeom prst="rect">
-            <a:avLst/>
-          </a:prstGeom>
-          <a:noFill/>
-          <a:ln/>
-        </p:spPr>
-        <p:txBody>
-          <a:bodyPr wrap="square" lIns="0" tIns="0" rIns="0" bIns="0" rtlCol="0" anchor="ctr"/>
-          <a:lstStyle/>
-          <a:p>
-            <a:pPr indent="0" marL="0">
-              <a:buNone/>
-            </a:pPr>
-            <a:r>
-              <a:rPr lang="en-US" sz="1500" dirty="0">
+            <a:off x="548640" y="2322576"/>
+            <a:ext cx="4389120" cy="256032"/>
+          </a:xfrm>
+          <a:prstGeom prst="rect">
+            <a:avLst/>
+          </a:prstGeom>
+          <a:noFill/>
+          <a:ln/>
+        </p:spPr>
+        <p:txBody>
+          <a:bodyPr wrap="square" lIns="0" tIns="0" rIns="0" bIns="0" rtlCol="0" anchor="ctr"/>
+          <a:lstStyle/>
+          <a:p>
+            <a:pPr indent="0" marL="0">
+              <a:buNone/>
+            </a:pPr>
+            <a:r>
+              <a:rPr lang="en-US" sz="1400" dirty="0">
                 <a:solidFill>
                   <a:srgbClr val="1B5538"/>
                 </a:solidFill>
@@ -10380,9 +10271,9 @@
                 <a:ea typeface="Segoe UI Semibold" pitchFamily="34" charset="-122"/>
                 <a:cs typeface="Segoe UI Semibold" pitchFamily="34" charset="-120"/>
               </a:rPr>
-              <a:t>Cluster manager</a:t>
-            </a:r>
-            <a:endParaRPr lang="en-US" sz="1500" dirty="0"/>
+              <a:t>Buyer</a:t>
+            </a:r>
+            <a:endParaRPr lang="en-US" sz="1400" dirty="0"/>
           </a:p>
         </p:txBody>
       </p:sp>
@@ -10394,8 +10285,8 @@
         </p:nvSpPr>
         <p:spPr>
           <a:xfrm>
-            <a:off x="548640" y="2743200"/>
-            <a:ext cx="4389120" cy="411480"/>
+            <a:off x="548640" y="2578608"/>
+            <a:ext cx="4389120" cy="347472"/>
           </a:xfrm>
           <a:prstGeom prst="rect">
             <a:avLst/>
@@ -10411,7 +10302,7 @@
               <a:buNone/>
             </a:pPr>
             <a:r>
-              <a:rPr lang="en-US" sz="1250" dirty="0">
+              <a:rPr lang="en-US" sz="1200" dirty="0">
                 <a:solidFill>
                   <a:srgbClr val="17201B"/>
                 </a:solidFill>
@@ -10419,9 +10310,9 @@
                 <a:ea typeface="Segoe UI" pitchFamily="34" charset="-122"/>
                 <a:cs typeface="Segoe UI" pitchFamily="34" charset="-120"/>
               </a:rPr>
-              <a:t>Sees all 128 farms; coordinates water, resources, buyers.</a:t>
-            </a:r>
-            <a:endParaRPr lang="en-US" sz="1250" dirty="0"/>
+              <a:t>Searches crops, sees farmer-approved details, requests farmers.</a:t>
+            </a:r>
+            <a:endParaRPr lang="en-US" sz="1200" dirty="0"/>
           </a:p>
         </p:txBody>
       </p:sp>
@@ -10433,24 +10324,24 @@
         </p:nvSpPr>
         <p:spPr>
           <a:xfrm>
-            <a:off x="548640" y="3200400"/>
-            <a:ext cx="4389120" cy="274320"/>
-          </a:xfrm>
-          <a:prstGeom prst="rect">
-            <a:avLst/>
-          </a:prstGeom>
-          <a:noFill/>
-          <a:ln/>
-        </p:spPr>
-        <p:txBody>
-          <a:bodyPr wrap="square" lIns="0" tIns="0" rIns="0" bIns="0" rtlCol="0" anchor="ctr"/>
-          <a:lstStyle/>
-          <a:p>
-            <a:pPr indent="0" marL="0">
-              <a:buNone/>
-            </a:pPr>
-            <a:r>
-              <a:rPr lang="en-US" sz="1500" dirty="0">
+            <a:off x="548640" y="2953512"/>
+            <a:ext cx="4389120" cy="256032"/>
+          </a:xfrm>
+          <a:prstGeom prst="rect">
+            <a:avLst/>
+          </a:prstGeom>
+          <a:noFill/>
+          <a:ln/>
+        </p:spPr>
+        <p:txBody>
+          <a:bodyPr wrap="square" lIns="0" tIns="0" rIns="0" bIns="0" rtlCol="0" anchor="ctr"/>
+          <a:lstStyle/>
+          <a:p>
+            <a:pPr indent="0" marL="0">
+              <a:buNone/>
+            </a:pPr>
+            <a:r>
+              <a:rPr lang="en-US" sz="1400" dirty="0">
                 <a:solidFill>
                   <a:srgbClr val="1B5538"/>
                 </a:solidFill>
@@ -10458,9 +10349,9 @@
                 <a:ea typeface="Segoe UI Semibold" pitchFamily="34" charset="-122"/>
                 <a:cs typeface="Segoe UI Semibold" pitchFamily="34" charset="-120"/>
               </a:rPr>
-              <a:t>Buyer</a:t>
-            </a:r>
-            <a:endParaRPr lang="en-US" sz="1500" dirty="0"/>
+              <a:t>Machinery &amp; tech owner</a:t>
+            </a:r>
+            <a:endParaRPr lang="en-US" sz="1400" dirty="0"/>
           </a:p>
         </p:txBody>
       </p:sp>
@@ -10472,8 +10363,8 @@
         </p:nvSpPr>
         <p:spPr>
           <a:xfrm>
-            <a:off x="548640" y="3474720"/>
-            <a:ext cx="4389120" cy="411480"/>
+            <a:off x="548640" y="3209544"/>
+            <a:ext cx="4389120" cy="347472"/>
           </a:xfrm>
           <a:prstGeom prst="rect">
             <a:avLst/>
@@ -10489,7 +10380,7 @@
               <a:buNone/>
             </a:pPr>
             <a:r>
-              <a:rPr lang="en-US" sz="1250" dirty="0">
+              <a:rPr lang="en-US" sz="1200" dirty="0">
                 <a:solidFill>
                   <a:srgbClr val="17201B"/>
                 </a:solidFill>
@@ -10497,9 +10388,9 @@
                 <a:ea typeface="Segoe UI" pitchFamily="34" charset="-122"/>
                 <a:cs typeface="Segoe UI" pitchFamily="34" charset="-120"/>
               </a:rPr>
-              <a:t>Posts requirements, sees pooled supply, accepts offers.</a:t>
-            </a:r>
-            <a:endParaRPr lang="en-US" sz="1250" dirty="0"/>
+              <a:t>Lists equipment and services; accepts bookings.</a:t>
+            </a:r>
+            <a:endParaRPr lang="en-US" sz="1200" dirty="0"/>
           </a:p>
         </p:txBody>
       </p:sp>
@@ -10511,24 +10402,24 @@
         </p:nvSpPr>
         <p:spPr>
           <a:xfrm>
-            <a:off x="548640" y="3931920"/>
-            <a:ext cx="4389120" cy="274320"/>
-          </a:xfrm>
-          <a:prstGeom prst="rect">
-            <a:avLst/>
-          </a:prstGeom>
-          <a:noFill/>
-          <a:ln/>
-        </p:spPr>
-        <p:txBody>
-          <a:bodyPr wrap="square" lIns="0" tIns="0" rIns="0" bIns="0" rtlCol="0" anchor="ctr"/>
-          <a:lstStyle/>
-          <a:p>
-            <a:pPr indent="0" marL="0">
-              <a:buNone/>
-            </a:pPr>
-            <a:r>
-              <a:rPr lang="en-US" sz="1500" dirty="0">
+            <a:off x="548640" y="3584448"/>
+            <a:ext cx="4389120" cy="256032"/>
+          </a:xfrm>
+          <a:prstGeom prst="rect">
+            <a:avLst/>
+          </a:prstGeom>
+          <a:noFill/>
+          <a:ln/>
+        </p:spPr>
+        <p:txBody>
+          <a:bodyPr wrap="square" lIns="0" tIns="0" rIns="0" bIns="0" rtlCol="0" anchor="ctr"/>
+          <a:lstStyle/>
+          <a:p>
+            <a:pPr indent="0" marL="0">
+              <a:buNone/>
+            </a:pPr>
+            <a:r>
+              <a:rPr lang="en-US" sz="1400" dirty="0">
                 <a:solidFill>
                   <a:srgbClr val="1B5538"/>
                 </a:solidFill>
@@ -10536,9 +10427,9 @@
                 <a:ea typeface="Segoe UI Semibold" pitchFamily="34" charset="-122"/>
                 <a:cs typeface="Segoe UI Semibold" pitchFamily="34" charset="-120"/>
               </a:rPr>
-              <a:t>Machinery owner</a:t>
-            </a:r>
-            <a:endParaRPr lang="en-US" sz="1500" dirty="0"/>
+              <a:t>Labour</a:t>
+            </a:r>
+            <a:endParaRPr lang="en-US" sz="1400" dirty="0"/>
           </a:p>
         </p:txBody>
       </p:sp>
@@ -10550,8 +10441,8 @@
         </p:nvSpPr>
         <p:spPr>
           <a:xfrm>
-            <a:off x="548640" y="4206240"/>
-            <a:ext cx="4389120" cy="411480"/>
+            <a:off x="548640" y="3840480"/>
+            <a:ext cx="4389120" cy="347472"/>
           </a:xfrm>
           <a:prstGeom prst="rect">
             <a:avLst/>
@@ -10567,7 +10458,7 @@
               <a:buNone/>
             </a:pPr>
             <a:r>
-              <a:rPr lang="en-US" sz="1250" dirty="0">
+              <a:rPr lang="en-US" sz="1200" dirty="0">
                 <a:solidFill>
                   <a:srgbClr val="17201B"/>
                 </a:solidFill>
@@ -10575,9 +10466,9 @@
                 <a:ea typeface="Segoe UI" pitchFamily="34" charset="-122"/>
                 <a:cs typeface="Segoe UI" pitchFamily="34" charset="-120"/>
               </a:rPr>
-              <a:t>Lists equipment and availability, accepts bookings.</a:t>
-            </a:r>
-            <a:endParaRPr lang="en-US" sz="1250" dirty="0"/>
+              <a:t>Lists skills, crops, rates and transport; accepts work.</a:t>
+            </a:r>
+            <a:endParaRPr lang="en-US" sz="1200" dirty="0"/>
           </a:p>
         </p:txBody>
       </p:sp>
@@ -10589,24 +10480,24 @@
         </p:nvSpPr>
         <p:spPr>
           <a:xfrm>
-            <a:off x="548640" y="4663440"/>
-            <a:ext cx="4389120" cy="274320"/>
-          </a:xfrm>
-          <a:prstGeom prst="rect">
-            <a:avLst/>
-          </a:prstGeom>
-          <a:noFill/>
-          <a:ln/>
-        </p:spPr>
-        <p:txBody>
-          <a:bodyPr wrap="square" lIns="0" tIns="0" rIns="0" bIns="0" rtlCol="0" anchor="ctr"/>
-          <a:lstStyle/>
-          <a:p>
-            <a:pPr indent="0" marL="0">
-              <a:buNone/>
-            </a:pPr>
-            <a:r>
-              <a:rPr lang="en-US" sz="1500" dirty="0">
+            <a:off x="548640" y="4215384"/>
+            <a:ext cx="4389120" cy="256032"/>
+          </a:xfrm>
+          <a:prstGeom prst="rect">
+            <a:avLst/>
+          </a:prstGeom>
+          <a:noFill/>
+          <a:ln/>
+        </p:spPr>
+        <p:txBody>
+          <a:bodyPr wrap="square" lIns="0" tIns="0" rIns="0" bIns="0" rtlCol="0" anchor="ctr"/>
+          <a:lstStyle/>
+          <a:p>
+            <a:pPr indent="0" marL="0">
+              <a:buNone/>
+            </a:pPr>
+            <a:r>
+              <a:rPr lang="en-US" sz="1400" dirty="0">
                 <a:solidFill>
                   <a:srgbClr val="1B5538"/>
                 </a:solidFill>
@@ -10614,9 +10505,9 @@
                 <a:ea typeface="Segoe UI Semibold" pitchFamily="34" charset="-122"/>
                 <a:cs typeface="Segoe UI Semibold" pitchFamily="34" charset="-120"/>
               </a:rPr>
-              <a:t>Labour</a:t>
-            </a:r>
-            <a:endParaRPr lang="en-US" sz="1500" dirty="0"/>
+              <a:t>Expert</a:t>
+            </a:r>
+            <a:endParaRPr lang="en-US" sz="1400" dirty="0"/>
           </a:p>
         </p:txBody>
       </p:sp>
@@ -10628,8 +10519,8 @@
         </p:nvSpPr>
         <p:spPr>
           <a:xfrm>
-            <a:off x="548640" y="4937760"/>
-            <a:ext cx="4389120" cy="411480"/>
+            <a:off x="548640" y="4471416"/>
+            <a:ext cx="4389120" cy="347472"/>
           </a:xfrm>
           <a:prstGeom prst="rect">
             <a:avLst/>
@@ -10645,7 +10536,7 @@
               <a:buNone/>
             </a:pPr>
             <a:r>
-              <a:rPr lang="en-US" sz="1250" dirty="0">
+              <a:rPr lang="en-US" sz="1200" dirty="0">
                 <a:solidFill>
                   <a:srgbClr val="17201B"/>
                 </a:solidFill>
@@ -10653,9 +10544,9 @@
                 <a:ea typeface="Segoe UI" pitchFamily="34" charset="-122"/>
                 <a:cs typeface="Segoe UI" pitchFamily="34" charset="-120"/>
               </a:rPr>
-              <a:t>Lists skills and availability, accepts and tracks work.</a:t>
-            </a:r>
-            <a:endParaRPr lang="en-US" sz="1250" dirty="0"/>
+              <a:t>Answers questions and books consultations, across 11 fields.</a:t>
+            </a:r>
+            <a:endParaRPr lang="en-US" sz="1200" dirty="0"/>
           </a:p>
         </p:txBody>
       </p:sp>
@@ -10667,24 +10558,24 @@
         </p:nvSpPr>
         <p:spPr>
           <a:xfrm>
-            <a:off x="548640" y="5394960"/>
-            <a:ext cx="4389120" cy="274320"/>
-          </a:xfrm>
-          <a:prstGeom prst="rect">
-            <a:avLst/>
-          </a:prstGeom>
-          <a:noFill/>
-          <a:ln/>
-        </p:spPr>
-        <p:txBody>
-          <a:bodyPr wrap="square" lIns="0" tIns="0" rIns="0" bIns="0" rtlCol="0" anchor="ctr"/>
-          <a:lstStyle/>
-          <a:p>
-            <a:pPr indent="0" marL="0">
-              <a:buNone/>
-            </a:pPr>
-            <a:r>
-              <a:rPr lang="en-US" sz="1500" dirty="0">
+            <a:off x="548640" y="4846320"/>
+            <a:ext cx="4389120" cy="256032"/>
+          </a:xfrm>
+          <a:prstGeom prst="rect">
+            <a:avLst/>
+          </a:prstGeom>
+          <a:noFill/>
+          <a:ln/>
+        </p:spPr>
+        <p:txBody>
+          <a:bodyPr wrap="square" lIns="0" tIns="0" rIns="0" bIns="0" rtlCol="0" anchor="ctr"/>
+          <a:lstStyle/>
+          <a:p>
+            <a:pPr indent="0" marL="0">
+              <a:buNone/>
+            </a:pPr>
+            <a:r>
+              <a:rPr lang="en-US" sz="1400" dirty="0">
                 <a:solidFill>
                   <a:srgbClr val="1B5538"/>
                 </a:solidFill>
@@ -10692,9 +10583,9 @@
                 <a:ea typeface="Segoe UI Semibold" pitchFamily="34" charset="-122"/>
                 <a:cs typeface="Segoe UI Semibold" pitchFamily="34" charset="-120"/>
               </a:rPr>
-              <a:t>Expert</a:t>
-            </a:r>
-            <a:endParaRPr lang="en-US" sz="1500" dirty="0"/>
+              <a:t>Community</a:t>
+            </a:r>
+            <a:endParaRPr lang="en-US" sz="1400" dirty="0"/>
           </a:p>
         </p:txBody>
       </p:sp>
@@ -10706,8 +10597,8 @@
         </p:nvSpPr>
         <p:spPr>
           <a:xfrm>
-            <a:off x="548640" y="5669280"/>
-            <a:ext cx="4389120" cy="411480"/>
+            <a:off x="548640" y="5102352"/>
+            <a:ext cx="4389120" cy="347472"/>
           </a:xfrm>
           <a:prstGeom prst="rect">
             <a:avLst/>
@@ -10723,7 +10614,7 @@
               <a:buNone/>
             </a:pPr>
             <a:r>
-              <a:rPr lang="en-US" sz="1250" dirty="0">
+              <a:rPr lang="en-US" sz="1200" dirty="0">
                 <a:solidFill>
                   <a:srgbClr val="17201B"/>
                 </a:solidFill>
@@ -10731,26 +10622,104 @@
                 <a:ea typeface="Segoe UI" pitchFamily="34" charset="-122"/>
                 <a:cs typeface="Segoe UI" pitchFamily="34" charset="-120"/>
               </a:rPr>
-              <a:t>Answers questions with farm data in view; schedules visits.</a:t>
-            </a:r>
-            <a:endParaRPr lang="en-US" sz="1250" dirty="0"/>
-          </a:p>
-        </p:txBody>
-      </p:sp>
-      <p:sp>
-        <p:nvSpPr>
-          <p:cNvPr id="18" name="Shape 16"/>
-          <p:cNvSpPr/>
-          <p:nvPr/>
-        </p:nvSpPr>
-        <p:spPr>
-          <a:xfrm>
-            <a:off x="5257800" y="1737360"/>
-            <a:ext cx="6400800" cy="3600450"/>
+              <a:t>Runs farmer groups, events and success stories.</a:t>
+            </a:r>
+            <a:endParaRPr lang="en-US" sz="1200" dirty="0"/>
+          </a:p>
+        </p:txBody>
+      </p:sp>
+      <p:sp>
+        <p:nvSpPr>
+          <p:cNvPr id="18" name="Text 16"/>
+          <p:cNvSpPr/>
+          <p:nvPr/>
+        </p:nvSpPr>
+        <p:spPr>
+          <a:xfrm>
+            <a:off x="548640" y="5477256"/>
+            <a:ext cx="4389120" cy="256032"/>
+          </a:xfrm>
+          <a:prstGeom prst="rect">
+            <a:avLst/>
+          </a:prstGeom>
+          <a:noFill/>
+          <a:ln/>
+        </p:spPr>
+        <p:txBody>
+          <a:bodyPr wrap="square" lIns="0" tIns="0" rIns="0" bIns="0" rtlCol="0" anchor="ctr"/>
+          <a:lstStyle/>
+          <a:p>
+            <a:pPr indent="0" marL="0">
+              <a:buNone/>
+            </a:pPr>
+            <a:r>
+              <a:rPr lang="en-US" sz="1400" dirty="0">
+                <a:solidFill>
+                  <a:srgbClr val="1B5538"/>
+                </a:solidFill>
+                <a:latin typeface="Segoe UI Semibold" pitchFamily="34" charset="0"/>
+                <a:ea typeface="Segoe UI Semibold" pitchFamily="34" charset="-122"/>
+                <a:cs typeface="Segoe UI Semibold" pitchFamily="34" charset="-120"/>
+              </a:rPr>
+              <a:t>Cluster manager</a:t>
+            </a:r>
+            <a:endParaRPr lang="en-US" sz="1400" dirty="0"/>
+          </a:p>
+        </p:txBody>
+      </p:sp>
+      <p:sp>
+        <p:nvSpPr>
+          <p:cNvPr id="19" name="Text 17"/>
+          <p:cNvSpPr/>
+          <p:nvPr/>
+        </p:nvSpPr>
+        <p:spPr>
+          <a:xfrm>
+            <a:off x="548640" y="5733288"/>
+            <a:ext cx="4389120" cy="347472"/>
+          </a:xfrm>
+          <a:prstGeom prst="rect">
+            <a:avLst/>
+          </a:prstGeom>
+          <a:noFill/>
+          <a:ln/>
+        </p:spPr>
+        <p:txBody>
+          <a:bodyPr wrap="square" lIns="0" tIns="0" rIns="0" bIns="0" rtlCol="0" anchor="t"/>
+          <a:lstStyle/>
+          <a:p>
+            <a:pPr indent="0" marL="0">
+              <a:buNone/>
+            </a:pPr>
+            <a:r>
+              <a:rPr lang="en-US" sz="1200" dirty="0">
+                <a:solidFill>
+                  <a:srgbClr val="17201B"/>
+                </a:solidFill>
+                <a:latin typeface="Segoe UI" pitchFamily="34" charset="0"/>
+                <a:ea typeface="Segoe UI" pitchFamily="34" charset="-122"/>
+                <a:cs typeface="Segoe UI" pitchFamily="34" charset="-120"/>
+              </a:rPr>
+              <a:t>Sees all 128 farms; coordinates water, resources, supply.</a:t>
+            </a:r>
+            <a:endParaRPr lang="en-US" sz="1200" dirty="0"/>
+          </a:p>
+        </p:txBody>
+      </p:sp>
+      <p:sp>
+        <p:nvSpPr>
+          <p:cNvPr id="20" name="Shape 18"/>
+          <p:cNvSpPr/>
+          <p:nvPr/>
+        </p:nvSpPr>
+        <p:spPr>
+          <a:xfrm>
+            <a:off x="5257800" y="1691640"/>
+            <a:ext cx="3108960" cy="2829639"/>
           </a:xfrm>
           <a:prstGeom prst="roundRect">
             <a:avLst>
-              <a:gd name="adj" fmla="val 2032"/>
+              <a:gd name="adj" fmla="val 2585"/>
             </a:avLst>
           </a:prstGeom>
           <a:solidFill>
@@ -10773,7 +10742,7 @@
       </p:sp>
       <p:pic>
         <p:nvPicPr>
-          <p:cNvPr id="19" name="Image 0" descr="assets/cluster-overview.png">    </p:cNvPr>
+          <p:cNvPr id="21" name="Image 0" descr="assets/buyer-view-crop.png">    </p:cNvPr>
           <p:cNvPicPr>
             <a:picLocks noChangeAspect="1"/>
           </p:cNvPicPr>
@@ -10787,8 +10756,8 @@
         </p:blipFill>
         <p:spPr>
           <a:xfrm>
-            <a:off x="5312664" y="1792224"/>
-            <a:ext cx="6291072" cy="3490722"/>
+            <a:off x="5312664" y="1746504"/>
+            <a:ext cx="2999232" cy="2719911"/>
           </a:xfrm>
           <a:prstGeom prst="rect">
             <a:avLst/>
@@ -10797,38 +10766,160 @@
       </p:pic>
       <p:sp>
         <p:nvSpPr>
-          <p:cNvPr id="20" name="Text 17"/>
-          <p:cNvSpPr/>
-          <p:nvPr/>
-        </p:nvSpPr>
-        <p:spPr>
-          <a:xfrm>
-            <a:off x="5257800" y="5440680"/>
-            <a:ext cx="6400800" cy="274320"/>
-          </a:xfrm>
-          <a:prstGeom prst="rect">
-            <a:avLst/>
-          </a:prstGeom>
-          <a:noFill/>
-          <a:ln/>
-        </p:spPr>
-        <p:txBody>
-          <a:bodyPr wrap="square" lIns="0" tIns="0" rIns="0" bIns="0" rtlCol="0" anchor="ctr"/>
-          <a:lstStyle/>
-          <a:p>
-            <a:pPr indent="0" marL="0">
-              <a:buNone/>
-            </a:pPr>
-            <a:r>
-              <a:rPr lang="en-US" sz="1100" i="1" dirty="0">
-                <a:solidFill>
-                  <a:srgbClr val="636C65"/>
+          <p:cNvPr id="22" name="Text 19"/>
+          <p:cNvSpPr/>
+          <p:nvPr/>
+        </p:nvSpPr>
+        <p:spPr>
+          <a:xfrm>
+            <a:off x="8595360" y="1691640"/>
+            <a:ext cx="3063240" cy="4023360"/>
+          </a:xfrm>
+          <a:prstGeom prst="rect">
+            <a:avLst/>
+          </a:prstGeom>
+          <a:noFill/>
+          <a:ln/>
+        </p:spPr>
+        <p:txBody>
+          <a:bodyPr wrap="square" lIns="0" tIns="0" rIns="0" bIns="0" rtlCol="0" anchor="t"/>
+          <a:lstStyle/>
+          <a:p>
+            <a:pPr indent="0" marL="0">
+              <a:spcAft>
+                <a:spcPts val="400"/>
+              </a:spcAft>
+              <a:buNone/>
+            </a:pPr>
+            <a:r>
+              <a:rPr lang="en-US" sz="1250" dirty="0">
+                <a:solidFill>
+                  <a:srgbClr val="17201B"/>
+                </a:solidFill>
+                <a:latin typeface="Segoe UI Semibold" pitchFamily="34" charset="0"/>
+                <a:ea typeface="Segoe UI Semibold" pitchFamily="34" charset="-122"/>
+                <a:cs typeface="Segoe UI Semibold" pitchFamily="34" charset="-120"/>
+              </a:rPr>
+              <a:t>Privacy by role</a:t>
+            </a:r>
+            <a:endParaRPr lang="en-US" sz="1250" dirty="0"/>
+          </a:p>
+          <a:p>
+            <a:pPr indent="0" marL="0">
+              <a:spcAft>
+                <a:spcPts val="400"/>
+              </a:spcAft>
+              <a:buNone/>
+            </a:pPr>
+            <a:r>
+              <a:rPr lang="en-US" sz="1250" dirty="0">
+                <a:solidFill>
+                  <a:srgbClr val="56615A"/>
                 </a:solidFill>
                 <a:latin typeface="Segoe UI" pitchFamily="34" charset="0"/>
                 <a:ea typeface="Segoe UI" pitchFamily="34" charset="-122"/>
                 <a:cs typeface="Segoe UI" pitchFamily="34" charset="-120"/>
               </a:rPr>
-              <a:t>Cluster overview in the working prototype. A farmer's decision updates what every other role sees.</a:t>
+              <a:t>Buyers see only what the farmer approved on each listing: never her phone number, finances or exact location. Labour sees the job's crop and village. Experts see the question and the field it is about.</a:t>
+            </a:r>
+            <a:endParaRPr lang="en-US" sz="1250" dirty="0"/>
+          </a:p>
+          <a:p>
+            <a:pPr indent="0" marL="0">
+              <a:spcAft>
+                <a:spcPts val="400"/>
+              </a:spcAft>
+              <a:buNone/>
+            </a:pPr>
+            <a:r>
+              <a:rPr lang="en-US" sz="1250" dirty="0">
+                <a:solidFill>
+                  <a:srgbClr val="000000"/>
+                </a:solidFill>
+                <a:latin typeface="Segoe UI" pitchFamily="34" charset="0"/>
+                <a:ea typeface="Segoe UI" pitchFamily="34" charset="-122"/>
+                <a:cs typeface="Segoe UI" pitchFamily="34" charset="-120"/>
+              </a:rPr>
+              <a:t> </a:t>
+            </a:r>
+            <a:endParaRPr lang="en-US" sz="1250" dirty="0"/>
+          </a:p>
+          <a:p>
+            <a:pPr indent="0" marL="0">
+              <a:spcAft>
+                <a:spcPts val="400"/>
+              </a:spcAft>
+              <a:buNone/>
+            </a:pPr>
+            <a:r>
+              <a:rPr lang="en-US" sz="1250" dirty="0">
+                <a:solidFill>
+                  <a:srgbClr val="17201B"/>
+                </a:solidFill>
+                <a:latin typeface="Segoe UI Semibold" pitchFamily="34" charset="0"/>
+                <a:ea typeface="Segoe UI Semibold" pitchFamily="34" charset="-122"/>
+                <a:cs typeface="Segoe UI Semibold" pitchFamily="34" charset="-120"/>
+              </a:rPr>
+              <a:t>Connected by notifications</a:t>
+            </a:r>
+            <a:endParaRPr lang="en-US" sz="1250" dirty="0"/>
+          </a:p>
+          <a:p>
+            <a:pPr indent="0" marL="0">
+              <a:spcAft>
+                <a:spcPts val="400"/>
+              </a:spcAft>
+              <a:buNone/>
+            </a:pPr>
+            <a:r>
+              <a:rPr lang="en-US" sz="1250" dirty="0">
+                <a:solidFill>
+                  <a:srgbClr val="56615A"/>
+                </a:solidFill>
+                <a:latin typeface="Segoe UI" pitchFamily="34" charset="0"/>
+                <a:ea typeface="Segoe UI" pitchFamily="34" charset="-122"/>
+                <a:cs typeface="Segoe UI" pitchFamily="34" charset="-120"/>
+              </a:rPr>
+              <a:t>Every request, offer and reply notifies the other side, from “Buyer requested your tomato crop” to “Expert consultation confirmed”.</a:t>
+            </a:r>
+            <a:endParaRPr lang="en-US" sz="1250" dirty="0"/>
+          </a:p>
+        </p:txBody>
+      </p:sp>
+      <p:sp>
+        <p:nvSpPr>
+          <p:cNvPr id="23" name="Text 20"/>
+          <p:cNvSpPr/>
+          <p:nvPr/>
+        </p:nvSpPr>
+        <p:spPr>
+          <a:xfrm>
+            <a:off x="5257800" y="4631007"/>
+            <a:ext cx="6400800" cy="274320"/>
+          </a:xfrm>
+          <a:prstGeom prst="rect">
+            <a:avLst/>
+          </a:prstGeom>
+          <a:noFill/>
+          <a:ln/>
+        </p:spPr>
+        <p:txBody>
+          <a:bodyPr wrap="square" lIns="0" tIns="0" rIns="0" bIns="0" rtlCol="0" anchor="ctr"/>
+          <a:lstStyle/>
+          <a:p>
+            <a:pPr indent="0" marL="0">
+              <a:buNone/>
+            </a:pPr>
+            <a:r>
+              <a:rPr lang="en-US" sz="1100" i="1" dirty="0">
+                <a:solidFill>
+                  <a:srgbClr val="636C65"/>
+                </a:solidFill>
+                <a:latin typeface="Segoe UI" pitchFamily="34" charset="0"/>
+                <a:ea typeface="Segoe UI" pitchFamily="34" charset="-122"/>
+                <a:cs typeface="Segoe UI" pitchFamily="34" charset="-120"/>
+              </a:rPr>
+              <a:t>What a buyer sees on “View crop”: farmer-approved details only</a:t>
             </a:r>
             <a:endParaRPr lang="en-US" sz="1100" dirty="0"/>
           </a:p>
@@ -11709,7 +11800,7 @@
                 <a:ea typeface="Segoe UI Semibold" pitchFamily="34" charset="-122"/>
                 <a:cs typeface="Segoe UI Semibold" pitchFamily="34" charset="-120"/>
               </a:rPr>
-              <a:t>≈36,000 L</a:t>
+              <a:t>≈15,000 L</a:t>
             </a:r>
             <a:endParaRPr lang="en-US" sz="2400" dirty="0"/>
           </a:p>
@@ -11748,7 +11839,7 @@
                 <a:ea typeface="Segoe UI" pitchFamily="34" charset="-122"/>
                 <a:cs typeface="Segoe UI" pitchFamily="34" charset="-120"/>
               </a:rPr>
-              <a:t>water and ≈11 kWh pumping avoided by one accepted irrigation suggestion (indicative)</a:t>
+              <a:t>water and ≈4 kWh pumping avoided on 1 acre by one accepted irrigation suggestion (indicative)</a:t>
             </a:r>
             <a:endParaRPr lang="en-US" sz="1300" dirty="0"/>
           </a:p>

</xml_diff>

<commit_message>
Pitch: talk track and deck updates for support and the real database
deck/TALK-TRACK.md: 3-minute pitch script, 21-step demo lines, close, and honest answers to likely judge questions. Deck slides 4, 7 and 11 mention government/private support and the cloud database with row-level security.
</commit_message>
<xml_diff>
--- a/deck/AgriCluster-pitch.pptx
+++ b/deck/AgriCluster-pitch.pptx
@@ -689,7 +689,7 @@
           <a:p>
             <a:r>
               <a:rPr lang="en-US" dirty="0"/>
-              <a:t>The model scales from one farm to a local cluster, then district clusters, multiple regions and a larger network. What scales is the intelligence and coordination layer; the farms stay small. We are simulation-first: the platform runs today on farmer input and shared sensors, and real sensors and data feeds plug into the same interfaces later. Every new cluster reuses the same engine, roles and screens, and brings more buyers, providers and experts to everyone.</a:t>
+              <a:t>The model scales from one farm to a local cluster, then district clusters, multiple regions and a larger network. What scales is the intelligence and coordination layer; the farms stay small. The prototype already stores its data in a real cloud database, with rules that keep each space private. Sensor readings are simulated for now, and real sensors and data feeds plug into the same interfaces later. Every new cluster reuses the same engine, roles and screens, and brings more buyers, providers and experts to everyone.</a:t>
             </a:r>
             <a:endParaRPr lang="en-US" dirty="0"/>
           </a:p>
@@ -3842,7 +3842,7 @@
                 <a:ea typeface="Segoe UI Semibold" pitchFamily="34" charset="-122"/>
                 <a:cs typeface="Segoe UI Semibold" pitchFamily="34" charset="-120"/>
               </a:rPr>
-              <a:t>Simulation-first</a:t>
+              <a:t>Real database, simulated sensors</a:t>
             </a:r>
             <a:endParaRPr lang="en-US" sz="1600" dirty="0"/>
           </a:p>
@@ -3881,7 +3881,7 @@
                 <a:ea typeface="Segoe UI" pitchFamily="34" charset="-122"/>
                 <a:cs typeface="Segoe UI" pitchFamily="34" charset="-120"/>
               </a:rPr>
-              <a:t>Works from farmer input and shared sensors today. Real sensors and data feeds plug into the same interfaces later.</a:t>
+              <a:t>Runs today on a cloud database with row-level security. Sensor readings are simulated; real sensors plug into the same interfaces later.</a:t>
             </a:r>
             <a:endParaRPr lang="en-US" sz="1300" dirty="0"/>
           </a:p>
@@ -7314,7 +7314,7 @@
                 <a:ea typeface="Segoe UI" pitchFamily="34" charset="-122"/>
                 <a:cs typeface="Segoe UI" pitchFamily="34" charset="-120"/>
               </a:rPr>
-              <a:t>Farmers, machinery and technology providers, labour, experts, community groups and buyers in one cluster.</a:t>
+              <a:t>Farmers, machinery and technology providers, labour, experts, buyers, and government and private support, in one cluster.</a:t>
             </a:r>
             <a:endParaRPr lang="en-US" sz="1400" dirty="0"/>
           </a:p>
@@ -10232,7 +10232,7 @@
                 <a:ea typeface="Segoe UI" pitchFamily="34" charset="-122"/>
                 <a:cs typeface="Segoe UI" pitchFamily="34" charset="-120"/>
               </a:rPr>
-              <a:t>Plans the season, requests resources, lists harvests.</a:t>
+              <a:t>Plans the season, finds support, requests resources, lists harvests.</a:t>
             </a:r>
             <a:endParaRPr lang="en-US" sz="1200" dirty="0"/>
           </a:p>

</xml_diff>